<commit_message>
fix: align AIJ PPTX typography, guides and AIRI branding
</commit_message>
<xml_diff>
--- a/plugins/paper-to-poster/skills/paper-to-poster/examples/compression_horizon_aij/poster.pptx
+++ b/plugins/paper-to-poster/skills/paper-to-poster/examples/compression_horizon_aij/poster.pptx
@@ -25,6 +25,14 @@
     <p:embeddedFont>
       <p:font typeface="SB Sans Display Semibold" pitchFamily="34" charset="0"/>
       <p:regular r:id="rId10"/>
+    </p:embeddedFont>
+    <p:embeddedFont>
+      <p:font typeface="SB Sans Text" pitchFamily="34" charset="0"/>
+      <p:regular r:id="rId7"/>
+    </p:embeddedFont>
+    <p:embeddedFont>
+      <p:font typeface="SB Sans Text Semibold" pitchFamily="34" charset="0"/>
+      <p:regular r:id="rId6"/>
     </p:embeddedFont>
   </p:embeddedFontLst>
   <p:defaultTextStyle>
@@ -3549,8 +3557,8 @@
         </p:nvSpPr>
         <p:spPr>
           <a:xfrm>
-            <a:off x="466427" y="3520380"/>
-            <a:ext cx="2836366" cy="9525"/>
+            <a:off x="476250" y="3903315"/>
+            <a:ext cx="2826693" cy="9525"/>
           </a:xfrm>
           <a:prstGeom prst="rect">
             <a:avLst/>
@@ -3579,8 +3587,8 @@
         </p:nvSpPr>
         <p:spPr>
           <a:xfrm>
-            <a:off x="466427" y="5111800"/>
-            <a:ext cx="2836366" cy="377875"/>
+            <a:off x="476250" y="5918746"/>
+            <a:ext cx="2826693" cy="390674"/>
           </a:xfrm>
           <a:prstGeom prst="rect">
             <a:avLst/>
@@ -3609,8 +3617,8 @@
         </p:nvSpPr>
         <p:spPr>
           <a:xfrm>
-            <a:off x="466427" y="6640860"/>
-            <a:ext cx="2836366" cy="9525"/>
+            <a:off x="476250" y="6453336"/>
+            <a:ext cx="2826693" cy="9525"/>
           </a:xfrm>
           <a:prstGeom prst="rect">
             <a:avLst/>
@@ -3639,8 +3647,8 @@
         </p:nvSpPr>
         <p:spPr>
           <a:xfrm>
-            <a:off x="3554760" y="3400276"/>
-            <a:ext cx="2836515" cy="9525"/>
+            <a:off x="3554909" y="3674120"/>
+            <a:ext cx="2826841" cy="9525"/>
           </a:xfrm>
           <a:prstGeom prst="rect">
             <a:avLst/>
@@ -3669,8 +3677,8 @@
         </p:nvSpPr>
         <p:spPr>
           <a:xfrm>
-            <a:off x="3554760" y="5485061"/>
-            <a:ext cx="2836515" cy="9525"/>
+            <a:off x="3554909" y="5973663"/>
+            <a:ext cx="2826841" cy="9525"/>
           </a:xfrm>
           <a:prstGeom prst="rect">
             <a:avLst/>
@@ -3693,37 +3701,7 @@
       </p:sp>
       <p:sp>
         <p:nvSpPr>
-          <p:cNvPr id="17" name="Rectangle 16"/>
-          <p:cNvSpPr/>
-          <p:nvPr/>
-        </p:nvSpPr>
-        <p:spPr>
-          <a:xfrm>
-            <a:off x="3554760" y="8147447"/>
-            <a:ext cx="2836515" cy="9525"/>
-          </a:xfrm>
-          <a:prstGeom prst="rect">
-            <a:avLst/>
-          </a:prstGeom>
-          <a:solidFill>
-            <a:srgbClr val="D5DAE6"/>
-          </a:solidFill>
-          <a:ln>
-            <a:noFill/>
-          </a:ln>
-          <a:effectLst/>
-        </p:spPr>
-        <p:txBody>
-          <a:bodyPr rtlCol="0" anchor="ctr"/>
-          <a:lstStyle/>
-          <a:p>
-            <a:pPr algn="ctr"/>
-          </a:p>
-        </p:txBody>
-      </p:sp>
-      <p:sp>
-        <p:nvSpPr>
-          <p:cNvPr id="18" name="Rounded Rectangle 17"/>
+          <p:cNvPr id="17" name="Rounded Rectangle 16"/>
           <p:cNvSpPr/>
           <p:nvPr/>
         </p:nvSpPr>
@@ -3755,7 +3733,7 @@
       </p:sp>
       <p:pic>
         <p:nvPicPr>
-          <p:cNvPr id="19" name="Picture 18" descr="figure_progressive_cramming.png"/>
+          <p:cNvPr id="18" name="Picture 17" descr="figure_progressive_cramming.png"/>
           <p:cNvPicPr>
             <a:picLocks noChangeAspect="1"/>
           </p:cNvPicPr>
@@ -3769,8 +3747,8 @@
         </p:blipFill>
         <p:spPr>
           <a:xfrm>
-            <a:off x="820936" y="1915269"/>
-            <a:ext cx="2127200" cy="1031081"/>
+            <a:off x="829568" y="2190750"/>
+            <a:ext cx="2119908" cy="1027509"/>
           </a:xfrm>
           <a:prstGeom prst="rect">
             <a:avLst/>
@@ -3779,7 +3757,7 @@
       </p:pic>
       <p:pic>
         <p:nvPicPr>
-          <p:cNvPr id="20" name="Picture 19" descr="figure_lowdim_projection.png"/>
+          <p:cNvPr id="19" name="Picture 18" descr="visual_abstract_pc1_pc2_joined.png"/>
           <p:cNvPicPr>
             <a:picLocks noChangeAspect="1"/>
           </p:cNvPicPr>
@@ -3793,8 +3771,8 @@
         </p:blipFill>
         <p:spPr>
           <a:xfrm>
-            <a:off x="891927" y="5489674"/>
-            <a:ext cx="1985367" cy="1007269"/>
+            <a:off x="688181" y="7483673"/>
+            <a:ext cx="2402681" cy="1125587"/>
           </a:xfrm>
           <a:prstGeom prst="rect">
             <a:avLst/>
@@ -3803,7 +3781,7 @@
       </p:pic>
       <p:pic>
         <p:nvPicPr>
-          <p:cNvPr id="21" name="Picture 20" descr="visual_abstract_pc1_pc2_joined.png"/>
+          <p:cNvPr id="20" name="Picture 19" descr="evaluation_protocol.png"/>
           <p:cNvPicPr>
             <a:picLocks noChangeAspect="1"/>
           </p:cNvPicPr>
@@ -3817,8 +3795,8 @@
         </p:blipFill>
         <p:spPr>
           <a:xfrm>
-            <a:off x="608261" y="7440513"/>
-            <a:ext cx="2552700" cy="1195834"/>
+            <a:off x="3554909" y="1692771"/>
+            <a:ext cx="2826841" cy="465534"/>
           </a:xfrm>
           <a:prstGeom prst="rect">
             <a:avLst/>
@@ -3827,7 +3805,7 @@
       </p:pic>
       <p:pic>
         <p:nvPicPr>
-          <p:cNvPr id="22" name="Picture 21" descr="evaluation_protocol.png"/>
+          <p:cNvPr id="21" name="Picture 20" descr="attention_knockout_cumulative_vertical.png"/>
           <p:cNvPicPr>
             <a:picLocks noChangeAspect="1"/>
           </p:cNvPicPr>
@@ -3841,8 +3819,8 @@
         </p:blipFill>
         <p:spPr>
           <a:xfrm>
-            <a:off x="3554760" y="1528316"/>
-            <a:ext cx="2836515" cy="467171"/>
+            <a:off x="3837533" y="4058841"/>
+            <a:ext cx="2261443" cy="903982"/>
           </a:xfrm>
           <a:prstGeom prst="rect">
             <a:avLst/>
@@ -3851,7 +3829,7 @@
       </p:pic>
       <p:pic>
         <p:nvPicPr>
-          <p:cNvPr id="23" name="Picture 22" descr="attention_knockout_cumulative_vertical.png"/>
+          <p:cNvPr id="22" name="Picture 21" descr="figure_full_cramming.png"/>
           <p:cNvPicPr>
             <a:picLocks noChangeAspect="1"/>
           </p:cNvPicPr>
@@ -3865,8 +3843,8 @@
         </p:blipFill>
         <p:spPr>
           <a:xfrm>
-            <a:off x="3838426" y="3678138"/>
-            <a:ext cx="2269182" cy="907107"/>
+            <a:off x="3625602" y="6967389"/>
+            <a:ext cx="2685455" cy="1029593"/>
           </a:xfrm>
           <a:prstGeom prst="rect">
             <a:avLst/>
@@ -3875,7 +3853,7 @@
       </p:pic>
       <p:pic>
         <p:nvPicPr>
-          <p:cNvPr id="24" name="Picture 23" descr="figure_full_cramming.png"/>
+          <p:cNvPr id="23" name="Picture 22" descr="image.png"/>
           <p:cNvPicPr>
             <a:picLocks noChangeAspect="1"/>
           </p:cNvPicPr>
@@ -3889,8 +3867,8 @@
         </p:blipFill>
         <p:spPr>
           <a:xfrm>
-            <a:off x="3838426" y="6260902"/>
-            <a:ext cx="2269182" cy="869900"/>
+            <a:off x="2705695" y="9430494"/>
+            <a:ext cx="529233" cy="220266"/>
           </a:xfrm>
           <a:prstGeom prst="rect">
             <a:avLst/>
@@ -3899,7 +3877,7 @@
       </p:pic>
       <p:pic>
         <p:nvPicPr>
-          <p:cNvPr id="25" name="Picture 24" descr="fusionbrain_combined_white.png"/>
+          <p:cNvPr id="24" name="Picture 23" descr="hse_logo_white.png"/>
           <p:cNvPicPr>
             <a:picLocks noChangeAspect="1"/>
           </p:cNvPicPr>
@@ -3913,8 +3891,8 @@
         </p:blipFill>
         <p:spPr>
           <a:xfrm>
-            <a:off x="2705249" y="9402812"/>
-            <a:ext cx="552152" cy="130820"/>
+            <a:off x="3342829" y="9430494"/>
+            <a:ext cx="919609" cy="220266"/>
           </a:xfrm>
           <a:prstGeom prst="rect">
             <a:avLst/>
@@ -3923,7 +3901,7 @@
       </p:pic>
       <p:pic>
         <p:nvPicPr>
-          <p:cNvPr id="26" name="Picture 25" descr="airi_logo_white.png"/>
+          <p:cNvPr id="25" name="Picture 24" descr="innopolis_logo_white.png"/>
           <p:cNvPicPr>
             <a:picLocks noChangeAspect="1"/>
           </p:cNvPicPr>
@@ -3937,8 +3915,8 @@
         </p:blipFill>
         <p:spPr>
           <a:xfrm>
-            <a:off x="3365302" y="9402812"/>
-            <a:ext cx="451098" cy="130820"/>
+            <a:off x="4370338" y="9430494"/>
+            <a:ext cx="883146" cy="220266"/>
           </a:xfrm>
           <a:prstGeom prst="rect">
             <a:avLst/>
@@ -3947,7 +3925,7 @@
       </p:pic>
       <p:pic>
         <p:nvPicPr>
-          <p:cNvPr id="27" name="Picture 26" descr="hse_logo_white.png"/>
+          <p:cNvPr id="26" name="Picture 25" descr="qr_code.png"/>
           <p:cNvPicPr>
             <a:picLocks noChangeAspect="1"/>
           </p:cNvPicPr>
@@ -3955,54 +3933,6 @@
         </p:nvPicPr>
         <p:blipFill>
           <a:blip r:embed="rId13"/>
-          <a:stretch>
-            <a:fillRect/>
-          </a:stretch>
-        </p:blipFill>
-        <p:spPr>
-          <a:xfrm>
-            <a:off x="3924300" y="9402812"/>
-            <a:ext cx="546050" cy="130820"/>
-          </a:xfrm>
-          <a:prstGeom prst="rect">
-            <a:avLst/>
-          </a:prstGeom>
-        </p:spPr>
-      </p:pic>
-      <p:pic>
-        <p:nvPicPr>
-          <p:cNvPr id="28" name="Picture 27" descr="innopolis_logo_white.png"/>
-          <p:cNvPicPr>
-            <a:picLocks noChangeAspect="1"/>
-          </p:cNvPicPr>
-          <p:nvPr/>
-        </p:nvPicPr>
-        <p:blipFill>
-          <a:blip r:embed="rId14"/>
-          <a:stretch>
-            <a:fillRect/>
-          </a:stretch>
-        </p:blipFill>
-        <p:spPr>
-          <a:xfrm>
-            <a:off x="4578251" y="9402812"/>
-            <a:ext cx="673596" cy="130820"/>
-          </a:xfrm>
-          <a:prstGeom prst="rect">
-            <a:avLst/>
-          </a:prstGeom>
-        </p:spPr>
-      </p:pic>
-      <p:pic>
-        <p:nvPicPr>
-          <p:cNvPr id="29" name="Picture 28" descr="qr_code.png"/>
-          <p:cNvPicPr>
-            <a:picLocks noChangeAspect="1"/>
-          </p:cNvPicPr>
-          <p:nvPr/>
-        </p:nvPicPr>
-        <p:blipFill>
-          <a:blip r:embed="rId15"/>
           <a:stretch>
             <a:fillRect/>
           </a:stretch>
@@ -4019,15 +3949,15 @@
       </p:pic>
       <p:graphicFrame>
         <p:nvGraphicFramePr>
-          <p:cNvPr id="30" name="Table 29"/>
+          <p:cNvPr id="27" name="Table 26"/>
           <p:cNvGraphicFramePr>
             <a:graphicFrameLocks noGrp="1"/>
           </p:cNvGraphicFramePr>
           <p:nvPr/>
         </p:nvGraphicFramePr>
         <p:xfrm>
-          <a:off x="466427" y="4074170"/>
-          <a:ext cx="2836367" cy="814090"/>
+          <a:off x="476250" y="4674989"/>
+          <a:ext cx="2826694" cy="814090"/>
         </p:xfrm>
         <a:graphic>
           <a:graphicData uri="http://schemas.openxmlformats.org/drawingml/2006/table">
@@ -4036,10 +3966,10 @@
                 <a:tableStyleId>{2D5ABB26-0587-4C30-8999-92F81FD0307C}</a:tableStyleId>
               </a:tblPr>
               <a:tblGrid>
-                <a:gridCol w="1039178"/>
-                <a:gridCol w="563880"/>
-                <a:gridCol w="742950"/>
-                <a:gridCol w="490359"/>
+                <a:gridCol w="1027748"/>
+                <a:gridCol w="570548"/>
+                <a:gridCol w="714375"/>
+                <a:gridCol w="514023"/>
               </a:tblGrid>
               <a:tr h="164009">
                 <a:tc>
@@ -4064,9 +3994,9 @@
                           <a:solidFill>
                             <a:srgbClr val="000000"/>
                           </a:solidFill>
-                          <a:latin typeface="SB Sans Display"/>
-                          <a:ea typeface="SB Sans Display"/>
-                          <a:cs typeface="SB Sans Display"/>
+                          <a:latin typeface="SB Sans Text"/>
+                          <a:ea typeface="SB Sans Text"/>
+                          <a:cs typeface="SB Sans Text"/>
                         </a:rPr>
                         <a:t>Model</a:t>
                       </a:r>
@@ -4113,9 +4043,9 @@
                           <a:solidFill>
                             <a:srgbClr val="000000"/>
                           </a:solidFill>
-                          <a:latin typeface="SB Sans Display"/>
-                          <a:ea typeface="SB Sans Display"/>
-                          <a:cs typeface="SB Sans Display"/>
+                          <a:latin typeface="SB Sans Text"/>
+                          <a:ea typeface="SB Sans Text"/>
+                          <a:cs typeface="SB Sans Text"/>
                         </a:rPr>
                         <a:t>Tokens</a:t>
                       </a:r>
@@ -4162,9 +4092,9 @@
                           <a:solidFill>
                             <a:srgbClr val="000000"/>
                           </a:solidFill>
-                          <a:latin typeface="SB Sans Display"/>
-                          <a:ea typeface="SB Sans Display"/>
-                          <a:cs typeface="SB Sans Display"/>
+                          <a:latin typeface="SB Sans Text"/>
+                          <a:ea typeface="SB Sans Text"/>
+                          <a:cs typeface="SB Sans Text"/>
                         </a:rPr>
                         <a:t>+LowDim</a:t>
                       </a:r>
@@ -4211,9 +4141,9 @@
                           <a:solidFill>
                             <a:srgbClr val="000000"/>
                           </a:solidFill>
-                          <a:latin typeface="SB Sans Display"/>
-                          <a:ea typeface="SB Sans Display"/>
-                          <a:cs typeface="SB Sans Display"/>
+                          <a:latin typeface="SB Sans Text"/>
+                          <a:ea typeface="SB Sans Text"/>
+                          <a:cs typeface="SB Sans Text"/>
                         </a:rPr>
                         <a:t>Boost</a:t>
                       </a:r>
@@ -4260,11 +4190,11 @@
                       <a:r>
                         <a:rPr lang="en-US" sz="700">
                           <a:solidFill>
-                            <a:srgbClr val="1B1F2A"/>
+                            <a:srgbClr val="000000"/>
                           </a:solidFill>
-                          <a:latin typeface="SB Sans Display Light"/>
-                          <a:ea typeface="SB Sans Display Light"/>
-                          <a:cs typeface="SB Sans Display Light"/>
+                          <a:latin typeface="SB Sans Text"/>
+                          <a:ea typeface="SB Sans Text"/>
+                          <a:cs typeface="SB Sans Text"/>
                         </a:rPr>
                         <a:t>Llama-3.1-8B</a:t>
                       </a:r>
@@ -4309,11 +4239,11 @@
                       <a:r>
                         <a:rPr lang="en-US" sz="700">
                           <a:solidFill>
-                            <a:srgbClr val="1B1F2A"/>
+                            <a:srgbClr val="000000"/>
                           </a:solidFill>
-                          <a:latin typeface="SB Sans Display Light"/>
-                          <a:ea typeface="SB Sans Display Light"/>
-                          <a:cs typeface="SB Sans Display Light"/>
+                          <a:latin typeface="SB Sans Text"/>
+                          <a:ea typeface="SB Sans Text"/>
+                          <a:cs typeface="SB Sans Text"/>
                         </a:rPr>
                         <a:t>1438</a:t>
                       </a:r>
@@ -4356,13 +4286,13 @@
                         <a:buNone/>
                       </a:pPr>
                       <a:r>
-                        <a:rPr lang="en-US" sz="700" b="1">
+                        <a:rPr lang="en-US" sz="700">
                           <a:solidFill>
                             <a:srgbClr val="1E9E53"/>
                           </a:solidFill>
-                          <a:latin typeface="SB Sans Display"/>
-                          <a:ea typeface="SB Sans Display"/>
-                          <a:cs typeface="SB Sans Display"/>
+                          <a:latin typeface="SB Sans Text"/>
+                          <a:ea typeface="SB Sans Text"/>
+                          <a:cs typeface="SB Sans Text"/>
                         </a:rPr>
                         <a:t>1697</a:t>
                       </a:r>
@@ -4407,11 +4337,11 @@
                       <a:r>
                         <a:rPr lang="en-US" sz="700">
                           <a:solidFill>
-                            <a:srgbClr val="1B1F2A"/>
+                            <a:srgbClr val="000000"/>
                           </a:solidFill>
-                          <a:latin typeface="SB Sans Display Light"/>
-                          <a:ea typeface="SB Sans Display Light"/>
-                          <a:cs typeface="SB Sans Display Light"/>
+                          <a:latin typeface="SB Sans Text"/>
+                          <a:ea typeface="SB Sans Text"/>
+                          <a:cs typeface="SB Sans Text"/>
                         </a:rPr>
                         <a:t>1.2×</a:t>
                       </a:r>
@@ -4458,11 +4388,11 @@
                       <a:r>
                         <a:rPr lang="en-US" sz="700">
                           <a:solidFill>
-                            <a:srgbClr val="1B1F2A"/>
+                            <a:srgbClr val="000000"/>
                           </a:solidFill>
-                          <a:latin typeface="SB Sans Display Light"/>
-                          <a:ea typeface="SB Sans Display Light"/>
-                          <a:cs typeface="SB Sans Display Light"/>
+                          <a:latin typeface="SB Sans Text"/>
+                          <a:ea typeface="SB Sans Text"/>
+                          <a:cs typeface="SB Sans Text"/>
                         </a:rPr>
                         <a:t>Pythia-1.4B</a:t>
                       </a:r>
@@ -4507,11 +4437,11 @@
                       <a:r>
                         <a:rPr lang="en-US" sz="700">
                           <a:solidFill>
-                            <a:srgbClr val="1B1F2A"/>
+                            <a:srgbClr val="000000"/>
                           </a:solidFill>
-                          <a:latin typeface="SB Sans Display Light"/>
-                          <a:ea typeface="SB Sans Display Light"/>
-                          <a:cs typeface="SB Sans Display Light"/>
+                          <a:latin typeface="SB Sans Text"/>
+                          <a:ea typeface="SB Sans Text"/>
+                          <a:cs typeface="SB Sans Text"/>
                         </a:rPr>
                         <a:t>430</a:t>
                       </a:r>
@@ -4556,11 +4486,11 @@
                       <a:r>
                         <a:rPr lang="en-US" sz="700">
                           <a:solidFill>
-                            <a:srgbClr val="1B1F2A"/>
+                            <a:srgbClr val="000000"/>
                           </a:solidFill>
-                          <a:latin typeface="SB Sans Display Light"/>
-                          <a:ea typeface="SB Sans Display Light"/>
-                          <a:cs typeface="SB Sans Display Light"/>
+                          <a:latin typeface="SB Sans Text"/>
+                          <a:ea typeface="SB Sans Text"/>
+                          <a:cs typeface="SB Sans Text"/>
                         </a:rPr>
                         <a:t>500</a:t>
                       </a:r>
@@ -4605,11 +4535,11 @@
                       <a:r>
                         <a:rPr lang="en-US" sz="700">
                           <a:solidFill>
-                            <a:srgbClr val="1B1F2A"/>
+                            <a:srgbClr val="000000"/>
                           </a:solidFill>
-                          <a:latin typeface="SB Sans Display Light"/>
-                          <a:ea typeface="SB Sans Display Light"/>
-                          <a:cs typeface="SB Sans Display Light"/>
+                          <a:latin typeface="SB Sans Text"/>
+                          <a:ea typeface="SB Sans Text"/>
+                          <a:cs typeface="SB Sans Text"/>
                         </a:rPr>
                         <a:t>1.2×</a:t>
                       </a:r>
@@ -4656,11 +4586,11 @@
                       <a:r>
                         <a:rPr lang="en-US" sz="700">
                           <a:solidFill>
-                            <a:srgbClr val="1B1F2A"/>
+                            <a:srgbClr val="000000"/>
                           </a:solidFill>
-                          <a:latin typeface="SB Sans Display Light"/>
-                          <a:ea typeface="SB Sans Display Light"/>
-                          <a:cs typeface="SB Sans Display Light"/>
+                          <a:latin typeface="SB Sans Text"/>
+                          <a:ea typeface="SB Sans Text"/>
+                          <a:cs typeface="SB Sans Text"/>
                         </a:rPr>
                         <a:t>SmolLM2-1.7B</a:t>
                       </a:r>
@@ -4705,11 +4635,11 @@
                       <a:r>
                         <a:rPr lang="en-US" sz="700">
                           <a:solidFill>
-                            <a:srgbClr val="1B1F2A"/>
+                            <a:srgbClr val="000000"/>
                           </a:solidFill>
-                          <a:latin typeface="SB Sans Display Light"/>
-                          <a:ea typeface="SB Sans Display Light"/>
-                          <a:cs typeface="SB Sans Display Light"/>
+                          <a:latin typeface="SB Sans Text"/>
+                          <a:ea typeface="SB Sans Text"/>
+                          <a:cs typeface="SB Sans Text"/>
                         </a:rPr>
                         <a:t>335</a:t>
                       </a:r>
@@ -4754,11 +4684,11 @@
                       <a:r>
                         <a:rPr lang="en-US" sz="700">
                           <a:solidFill>
-                            <a:srgbClr val="1B1F2A"/>
+                            <a:srgbClr val="000000"/>
                           </a:solidFill>
-                          <a:latin typeface="SB Sans Display Light"/>
-                          <a:ea typeface="SB Sans Display Light"/>
-                          <a:cs typeface="SB Sans Display Light"/>
+                          <a:latin typeface="SB Sans Text"/>
+                          <a:ea typeface="SB Sans Text"/>
+                          <a:cs typeface="SB Sans Text"/>
                         </a:rPr>
                         <a:t>957</a:t>
                       </a:r>
@@ -4803,11 +4733,11 @@
                       <a:r>
                         <a:rPr lang="en-US" sz="700">
                           <a:solidFill>
-                            <a:srgbClr val="1B1F2A"/>
+                            <a:srgbClr val="000000"/>
                           </a:solidFill>
-                          <a:latin typeface="SB Sans Display Light"/>
-                          <a:ea typeface="SB Sans Display Light"/>
-                          <a:cs typeface="SB Sans Display Light"/>
+                          <a:latin typeface="SB Sans Text"/>
+                          <a:ea typeface="SB Sans Text"/>
+                          <a:cs typeface="SB Sans Text"/>
                         </a:rPr>
                         <a:t>2.9×</a:t>
                       </a:r>
@@ -4854,11 +4784,11 @@
                       <a:r>
                         <a:rPr lang="en-US" sz="700">
                           <a:solidFill>
-                            <a:srgbClr val="1B1F2A"/>
+                            <a:srgbClr val="000000"/>
                           </a:solidFill>
-                          <a:latin typeface="SB Sans Display Light"/>
-                          <a:ea typeface="SB Sans Display Light"/>
-                          <a:cs typeface="SB Sans Display Light"/>
+                          <a:latin typeface="SB Sans Text"/>
+                          <a:ea typeface="SB Sans Text"/>
+                          <a:cs typeface="SB Sans Text"/>
                         </a:rPr>
                         <a:t>Gemma-3-4B</a:t>
                       </a:r>
@@ -4903,11 +4833,11 @@
                       <a:r>
                         <a:rPr lang="en-US" sz="700">
                           <a:solidFill>
-                            <a:srgbClr val="1B1F2A"/>
+                            <a:srgbClr val="000000"/>
                           </a:solidFill>
-                          <a:latin typeface="SB Sans Display Light"/>
-                          <a:ea typeface="SB Sans Display Light"/>
-                          <a:cs typeface="SB Sans Display Light"/>
+                          <a:latin typeface="SB Sans Text"/>
+                          <a:ea typeface="SB Sans Text"/>
+                          <a:cs typeface="SB Sans Text"/>
                         </a:rPr>
                         <a:t>214</a:t>
                       </a:r>
@@ -4952,11 +4882,11 @@
                       <a:r>
                         <a:rPr lang="en-US" sz="700">
                           <a:solidFill>
-                            <a:srgbClr val="1B1F2A"/>
+                            <a:srgbClr val="000000"/>
                           </a:solidFill>
-                          <a:latin typeface="SB Sans Display Light"/>
-                          <a:ea typeface="SB Sans Display Light"/>
-                          <a:cs typeface="SB Sans Display Light"/>
+                          <a:latin typeface="SB Sans Text"/>
+                          <a:ea typeface="SB Sans Text"/>
+                          <a:cs typeface="SB Sans Text"/>
                         </a:rPr>
                         <a:t>697</a:t>
                       </a:r>
@@ -4999,13 +4929,13 @@
                         <a:buNone/>
                       </a:pPr>
                       <a:r>
-                        <a:rPr lang="en-US" sz="700" b="1">
+                        <a:rPr lang="en-US" sz="700">
                           <a:solidFill>
                             <a:srgbClr val="1E9E53"/>
                           </a:solidFill>
-                          <a:latin typeface="SB Sans Display"/>
-                          <a:ea typeface="SB Sans Display"/>
-                          <a:cs typeface="SB Sans Display"/>
+                          <a:latin typeface="SB Sans Text"/>
+                          <a:ea typeface="SB Sans Text"/>
+                          <a:cs typeface="SB Sans Text"/>
                         </a:rPr>
                         <a:t>3.3×</a:t>
                       </a:r>
@@ -5037,15 +4967,15 @@
       </p:graphicFrame>
       <p:graphicFrame>
         <p:nvGraphicFramePr>
-          <p:cNvPr id="31" name="Table 30"/>
+          <p:cNvPr id="28" name="Table 27"/>
           <p:cNvGraphicFramePr>
             <a:graphicFrameLocks noGrp="1"/>
           </p:cNvGraphicFramePr>
           <p:nvPr/>
         </p:nvGraphicFramePr>
         <p:xfrm>
-          <a:off x="3554760" y="2325291"/>
-          <a:ext cx="2836516" cy="650379"/>
+          <a:off x="3554909" y="2488109"/>
+          <a:ext cx="2826842" cy="650379"/>
         </p:xfrm>
         <a:graphic>
           <a:graphicData uri="http://schemas.openxmlformats.org/drawingml/2006/table">
@@ -5054,11 +4984,11 @@
                 <a:tableStyleId>{2D5ABB26-0587-4C30-8999-92F81FD0307C}</a:tableStyleId>
               </a:tblPr>
               <a:tblGrid>
-                <a:gridCol w="757238"/>
-                <a:gridCol w="465773"/>
-                <a:gridCol w="520065"/>
-                <a:gridCol w="519112"/>
-                <a:gridCol w="574328"/>
+                <a:gridCol w="753428"/>
+                <a:gridCol w="471488"/>
+                <a:gridCol w="501968"/>
+                <a:gridCol w="534352"/>
+                <a:gridCol w="565606"/>
               </a:tblGrid>
               <a:tr h="164009">
                 <a:tc>
@@ -5083,9 +5013,9 @@
                           <a:solidFill>
                             <a:srgbClr val="000000"/>
                           </a:solidFill>
-                          <a:latin typeface="SB Sans Display"/>
-                          <a:ea typeface="SB Sans Display"/>
-                          <a:cs typeface="SB Sans Display"/>
+                          <a:latin typeface="SB Sans Text"/>
+                          <a:ea typeface="SB Sans Text"/>
+                          <a:cs typeface="SB Sans Text"/>
                         </a:rPr>
                         <a:t>Model</a:t>
                       </a:r>
@@ -5132,9 +5062,9 @@
                           <a:solidFill>
                             <a:srgbClr val="000000"/>
                           </a:solidFill>
-                          <a:latin typeface="SB Sans Display"/>
-                          <a:ea typeface="SB Sans Display"/>
-                          <a:cs typeface="SB Sans Display"/>
+                          <a:latin typeface="SB Sans Text"/>
+                          <a:ea typeface="SB Sans Text"/>
+                          <a:cs typeface="SB Sans Text"/>
                         </a:rPr>
                         <a:t>HS base</a:t>
                       </a:r>
@@ -5181,9 +5111,9 @@
                           <a:solidFill>
                             <a:srgbClr val="000000"/>
                           </a:solidFill>
-                          <a:latin typeface="SB Sans Display"/>
-                          <a:ea typeface="SB Sans Display"/>
-                          <a:cs typeface="SB Sans Display"/>
+                          <a:latin typeface="SB Sans Text"/>
+                          <a:ea typeface="SB Sans Text"/>
+                          <a:cs typeface="SB Sans Text"/>
                         </a:rPr>
                         <a:t>HS +emb</a:t>
                       </a:r>
@@ -5230,9 +5160,9 @@
                           <a:solidFill>
                             <a:srgbClr val="000000"/>
                           </a:solidFill>
-                          <a:latin typeface="SB Sans Display"/>
-                          <a:ea typeface="SB Sans Display"/>
-                          <a:cs typeface="SB Sans Display"/>
+                          <a:latin typeface="SB Sans Text"/>
+                          <a:ea typeface="SB Sans Text"/>
+                          <a:cs typeface="SB Sans Text"/>
                         </a:rPr>
                         <a:t>ARC base</a:t>
                       </a:r>
@@ -5279,9 +5209,9 @@
                           <a:solidFill>
                             <a:srgbClr val="000000"/>
                           </a:solidFill>
-                          <a:latin typeface="SB Sans Display"/>
-                          <a:ea typeface="SB Sans Display"/>
-                          <a:cs typeface="SB Sans Display"/>
+                          <a:latin typeface="SB Sans Text"/>
+                          <a:ea typeface="SB Sans Text"/>
+                          <a:cs typeface="SB Sans Text"/>
                         </a:rPr>
                         <a:t>ARC +emb</a:t>
                       </a:r>
@@ -5328,11 +5258,11 @@
                       <a:r>
                         <a:rPr lang="en-US" sz="700">
                           <a:solidFill>
-                            <a:srgbClr val="1B1F2A"/>
+                            <a:srgbClr val="000000"/>
                           </a:solidFill>
-                          <a:latin typeface="SB Sans Display Light"/>
-                          <a:ea typeface="SB Sans Display Light"/>
-                          <a:cs typeface="SB Sans Display Light"/>
+                          <a:latin typeface="SB Sans Text"/>
+                          <a:ea typeface="SB Sans Text"/>
+                          <a:cs typeface="SB Sans Text"/>
                         </a:rPr>
                         <a:t>Pythia-1.4B</a:t>
                       </a:r>
@@ -5377,11 +5307,11 @@
                       <a:r>
                         <a:rPr lang="en-US" sz="700">
                           <a:solidFill>
-                            <a:srgbClr val="1B1F2A"/>
+                            <a:srgbClr val="000000"/>
                           </a:solidFill>
-                          <a:latin typeface="SB Sans Display Light"/>
-                          <a:ea typeface="SB Sans Display Light"/>
-                          <a:cs typeface="SB Sans Display Light"/>
+                          <a:latin typeface="SB Sans Text"/>
+                          <a:ea typeface="SB Sans Text"/>
+                          <a:cs typeface="SB Sans Text"/>
                         </a:rPr>
                         <a:t>44.0%</a:t>
                       </a:r>
@@ -5428,9 +5358,9 @@
                           <a:solidFill>
                             <a:srgbClr val="C0392B"/>
                           </a:solidFill>
-                          <a:latin typeface="SB Sans Display Light"/>
-                          <a:ea typeface="SB Sans Display Light"/>
-                          <a:cs typeface="SB Sans Display Light"/>
+                          <a:latin typeface="SB Sans Text"/>
+                          <a:ea typeface="SB Sans Text"/>
+                          <a:cs typeface="SB Sans Text"/>
                         </a:rPr>
                         <a:t>37.6%</a:t>
                       </a:r>
@@ -5475,11 +5405,11 @@
                       <a:r>
                         <a:rPr lang="en-US" sz="700">
                           <a:solidFill>
-                            <a:srgbClr val="1B1F2A"/>
+                            <a:srgbClr val="000000"/>
                           </a:solidFill>
-                          <a:latin typeface="SB Sans Display Light"/>
-                          <a:ea typeface="SB Sans Display Light"/>
-                          <a:cs typeface="SB Sans Display Light"/>
+                          <a:latin typeface="SB Sans Text"/>
+                          <a:ea typeface="SB Sans Text"/>
+                          <a:cs typeface="SB Sans Text"/>
                         </a:rPr>
                         <a:t>53.1%</a:t>
                       </a:r>
@@ -5526,9 +5456,9 @@
                           <a:solidFill>
                             <a:srgbClr val="C0392B"/>
                           </a:solidFill>
-                          <a:latin typeface="SB Sans Display Light"/>
-                          <a:ea typeface="SB Sans Display Light"/>
-                          <a:cs typeface="SB Sans Display Light"/>
+                          <a:latin typeface="SB Sans Text"/>
+                          <a:ea typeface="SB Sans Text"/>
+                          <a:cs typeface="SB Sans Text"/>
                         </a:rPr>
                         <a:t>49.1%</a:t>
                       </a:r>
@@ -5575,11 +5505,11 @@
                       <a:r>
                         <a:rPr lang="en-US" sz="700">
                           <a:solidFill>
-                            <a:srgbClr val="1B1F2A"/>
+                            <a:srgbClr val="000000"/>
                           </a:solidFill>
-                          <a:latin typeface="SB Sans Display Light"/>
-                          <a:ea typeface="SB Sans Display Light"/>
-                          <a:cs typeface="SB Sans Display Light"/>
+                          <a:latin typeface="SB Sans Text"/>
+                          <a:ea typeface="SB Sans Text"/>
+                          <a:cs typeface="SB Sans Text"/>
                         </a:rPr>
                         <a:t>SmolLM2-1.7B</a:t>
                       </a:r>
@@ -5624,11 +5554,11 @@
                       <a:r>
                         <a:rPr lang="en-US" sz="700">
                           <a:solidFill>
-                            <a:srgbClr val="1B1F2A"/>
+                            <a:srgbClr val="000000"/>
                           </a:solidFill>
-                          <a:latin typeface="SB Sans Display Light"/>
-                          <a:ea typeface="SB Sans Display Light"/>
-                          <a:cs typeface="SB Sans Display Light"/>
+                          <a:latin typeface="SB Sans Text"/>
+                          <a:ea typeface="SB Sans Text"/>
+                          <a:cs typeface="SB Sans Text"/>
                         </a:rPr>
                         <a:t>53.6%</a:t>
                       </a:r>
@@ -5675,9 +5605,9 @@
                           <a:solidFill>
                             <a:srgbClr val="C0392B"/>
                           </a:solidFill>
-                          <a:latin typeface="SB Sans Display Light"/>
-                          <a:ea typeface="SB Sans Display Light"/>
-                          <a:cs typeface="SB Sans Display Light"/>
+                          <a:latin typeface="SB Sans Text"/>
+                          <a:ea typeface="SB Sans Text"/>
+                          <a:cs typeface="SB Sans Text"/>
                         </a:rPr>
                         <a:t>37.0%</a:t>
                       </a:r>
@@ -5722,11 +5652,11 @@
                       <a:r>
                         <a:rPr lang="en-US" sz="700">
                           <a:solidFill>
-                            <a:srgbClr val="1B1F2A"/>
+                            <a:srgbClr val="000000"/>
                           </a:solidFill>
-                          <a:latin typeface="SB Sans Display Light"/>
-                          <a:ea typeface="SB Sans Display Light"/>
-                          <a:cs typeface="SB Sans Display Light"/>
+                          <a:latin typeface="SB Sans Text"/>
+                          <a:ea typeface="SB Sans Text"/>
+                          <a:cs typeface="SB Sans Text"/>
                         </a:rPr>
                         <a:t>67.3%</a:t>
                       </a:r>
@@ -5773,9 +5703,9 @@
                           <a:solidFill>
                             <a:srgbClr val="C0392B"/>
                           </a:solidFill>
-                          <a:latin typeface="SB Sans Display Light"/>
-                          <a:ea typeface="SB Sans Display Light"/>
-                          <a:cs typeface="SB Sans Display Light"/>
+                          <a:latin typeface="SB Sans Text"/>
+                          <a:ea typeface="SB Sans Text"/>
+                          <a:cs typeface="SB Sans Text"/>
                         </a:rPr>
                         <a:t>56.0%</a:t>
                       </a:r>
@@ -5822,11 +5752,11 @@
                       <a:r>
                         <a:rPr lang="en-US" sz="700">
                           <a:solidFill>
-                            <a:srgbClr val="1B1F2A"/>
+                            <a:srgbClr val="000000"/>
                           </a:solidFill>
-                          <a:latin typeface="SB Sans Display Light"/>
-                          <a:ea typeface="SB Sans Display Light"/>
-                          <a:cs typeface="SB Sans Display Light"/>
+                          <a:latin typeface="SB Sans Text"/>
+                          <a:ea typeface="SB Sans Text"/>
+                          <a:cs typeface="SB Sans Text"/>
                         </a:rPr>
                         <a:t>Llama-3.1-8B</a:t>
                       </a:r>
@@ -5871,11 +5801,11 @@
                       <a:r>
                         <a:rPr lang="en-US" sz="700">
                           <a:solidFill>
-                            <a:srgbClr val="1B1F2A"/>
+                            <a:srgbClr val="000000"/>
                           </a:solidFill>
-                          <a:latin typeface="SB Sans Display Light"/>
-                          <a:ea typeface="SB Sans Display Light"/>
-                          <a:cs typeface="SB Sans Display Light"/>
+                          <a:latin typeface="SB Sans Text"/>
+                          <a:ea typeface="SB Sans Text"/>
+                          <a:cs typeface="SB Sans Text"/>
                         </a:rPr>
                         <a:t>61.9%</a:t>
                       </a:r>
@@ -5922,9 +5852,9 @@
                           <a:solidFill>
                             <a:srgbClr val="C0392B"/>
                           </a:solidFill>
-                          <a:latin typeface="SB Sans Display Light"/>
-                          <a:ea typeface="SB Sans Display Light"/>
-                          <a:cs typeface="SB Sans Display Light"/>
+                          <a:latin typeface="SB Sans Text"/>
+                          <a:ea typeface="SB Sans Text"/>
+                          <a:cs typeface="SB Sans Text"/>
                         </a:rPr>
                         <a:t>40.8%</a:t>
                       </a:r>
@@ -5969,11 +5899,11 @@
                       <a:r>
                         <a:rPr lang="en-US" sz="700">
                           <a:solidFill>
-                            <a:srgbClr val="1B1F2A"/>
+                            <a:srgbClr val="000000"/>
                           </a:solidFill>
-                          <a:latin typeface="SB Sans Display Light"/>
-                          <a:ea typeface="SB Sans Display Light"/>
-                          <a:cs typeface="SB Sans Display Light"/>
+                          <a:latin typeface="SB Sans Text"/>
+                          <a:ea typeface="SB Sans Text"/>
+                          <a:cs typeface="SB Sans Text"/>
                         </a:rPr>
                         <a:t>63.5%</a:t>
                       </a:r>
@@ -6020,9 +5950,9 @@
                           <a:solidFill>
                             <a:srgbClr val="C0392B"/>
                           </a:solidFill>
-                          <a:latin typeface="SB Sans Display Light"/>
-                          <a:ea typeface="SB Sans Display Light"/>
-                          <a:cs typeface="SB Sans Display Light"/>
+                          <a:latin typeface="SB Sans Text"/>
+                          <a:ea typeface="SB Sans Text"/>
+                          <a:cs typeface="SB Sans Text"/>
                         </a:rPr>
                         <a:t>43.3%</a:t>
                       </a:r>
@@ -6054,15 +5984,15 @@
       </p:graphicFrame>
       <p:graphicFrame>
         <p:nvGraphicFramePr>
-          <p:cNvPr id="32" name="Table 31"/>
+          <p:cNvPr id="29" name="Table 28"/>
           <p:cNvGraphicFramePr>
             <a:graphicFrameLocks noGrp="1"/>
           </p:cNvGraphicFramePr>
           <p:nvPr/>
         </p:nvGraphicFramePr>
         <p:xfrm>
-          <a:off x="3554760" y="7184678"/>
-          <a:ext cx="2836514" cy="814090"/>
+          <a:off x="3554909" y="8050857"/>
+          <a:ext cx="2826843" cy="814090"/>
         </p:xfrm>
         <a:graphic>
           <a:graphicData uri="http://schemas.openxmlformats.org/drawingml/2006/table">
@@ -6071,10 +6001,10 @@
                 <a:tableStyleId>{2D5ABB26-0587-4C30-8999-92F81FD0307C}</a:tableStyleId>
               </a:tblPr>
               <a:tblGrid>
-                <a:gridCol w="1140142"/>
-                <a:gridCol w="541020"/>
-                <a:gridCol w="599122"/>
-                <a:gridCol w="556230"/>
+                <a:gridCol w="1195388"/>
+                <a:gridCol w="543878"/>
+                <a:gridCol w="543878"/>
+                <a:gridCol w="543699"/>
               </a:tblGrid>
               <a:tr h="164009">
                 <a:tc>
@@ -6099,9 +6029,9 @@
                           <a:solidFill>
                             <a:srgbClr val="000000"/>
                           </a:solidFill>
-                          <a:latin typeface="SB Sans Display"/>
-                          <a:ea typeface="SB Sans Display"/>
-                          <a:cs typeface="SB Sans Display"/>
+                          <a:latin typeface="SB Sans Text"/>
+                          <a:ea typeface="SB Sans Text"/>
+                          <a:cs typeface="SB Sans Text"/>
                         </a:rPr>
                         <a:t>Model / type</a:t>
                       </a:r>
@@ -6148,9 +6078,9 @@
                           <a:solidFill>
                             <a:srgbClr val="000000"/>
                           </a:solidFill>
-                          <a:latin typeface="SB Sans Display"/>
-                          <a:ea typeface="SB Sans Display"/>
-                          <a:cs typeface="SB Sans Display"/>
+                          <a:latin typeface="SB Sans Text"/>
+                          <a:ea typeface="SB Sans Text"/>
+                          <a:cs typeface="SB Sans Text"/>
                         </a:rPr>
                         <a:t>Tokens</a:t>
                       </a:r>
@@ -6197,9 +6127,9 @@
                           <a:solidFill>
                             <a:srgbClr val="000000"/>
                           </a:solidFill>
-                          <a:latin typeface="SB Sans Display"/>
-                          <a:ea typeface="SB Sans Display"/>
-                          <a:cs typeface="SB Sans Display"/>
+                          <a:latin typeface="SB Sans Text"/>
+                          <a:ea typeface="SB Sans Text"/>
+                          <a:cs typeface="SB Sans Text"/>
                         </a:rPr>
                         <a:t>TF acc.</a:t>
                       </a:r>
@@ -6246,9 +6176,9 @@
                           <a:solidFill>
                             <a:srgbClr val="000000"/>
                           </a:solidFill>
-                          <a:latin typeface="SB Sans Display"/>
-                          <a:ea typeface="SB Sans Display"/>
-                          <a:cs typeface="SB Sans Display"/>
+                          <a:latin typeface="SB Sans Text"/>
+                          <a:ea typeface="SB Sans Text"/>
+                          <a:cs typeface="SB Sans Text"/>
                         </a:rPr>
                         <a:t>Greedy</a:t>
                       </a:r>
@@ -6295,11 +6225,11 @@
                       <a:r>
                         <a:rPr lang="en-US" sz="700">
                           <a:solidFill>
-                            <a:srgbClr val="1B1F2A"/>
+                            <a:srgbClr val="000000"/>
                           </a:solidFill>
-                          <a:latin typeface="SB Sans Display Light"/>
-                          <a:ea typeface="SB Sans Display Light"/>
-                          <a:cs typeface="SB Sans Display Light"/>
+                          <a:latin typeface="SB Sans Text"/>
+                          <a:ea typeface="SB Sans Text"/>
+                          <a:cs typeface="SB Sans Text"/>
                         </a:rPr>
                         <a:t>Llama-8B / full</a:t>
                       </a:r>
@@ -6344,11 +6274,11 @@
                       <a:r>
                         <a:rPr lang="en-US" sz="700">
                           <a:solidFill>
-                            <a:srgbClr val="1B1F2A"/>
+                            <a:srgbClr val="000000"/>
                           </a:solidFill>
-                          <a:latin typeface="SB Sans Display Light"/>
-                          <a:ea typeface="SB Sans Display Light"/>
-                          <a:cs typeface="SB Sans Display Light"/>
+                          <a:latin typeface="SB Sans Text"/>
+                          <a:ea typeface="SB Sans Text"/>
+                          <a:cs typeface="SB Sans Text"/>
                         </a:rPr>
                         <a:t>1568</a:t>
                       </a:r>
@@ -6393,11 +6323,11 @@
                       <a:r>
                         <a:rPr lang="en-US" sz="700">
                           <a:solidFill>
-                            <a:srgbClr val="1B1F2A"/>
+                            <a:srgbClr val="000000"/>
                           </a:solidFill>
-                          <a:latin typeface="SB Sans Display Light"/>
-                          <a:ea typeface="SB Sans Display Light"/>
-                          <a:cs typeface="SB Sans Display Light"/>
+                          <a:latin typeface="SB Sans Text"/>
+                          <a:ea typeface="SB Sans Text"/>
+                          <a:cs typeface="SB Sans Text"/>
                         </a:rPr>
                         <a:t>99.96%</a:t>
                       </a:r>
@@ -6444,9 +6374,9 @@
                           <a:solidFill>
                             <a:srgbClr val="C0392B"/>
                           </a:solidFill>
-                          <a:latin typeface="SB Sans Display Light"/>
-                          <a:ea typeface="SB Sans Display Light"/>
-                          <a:cs typeface="SB Sans Display Light"/>
+                          <a:latin typeface="SB Sans Text"/>
+                          <a:ea typeface="SB Sans Text"/>
+                          <a:cs typeface="SB Sans Text"/>
                         </a:rPr>
                         <a:t>40.4%</a:t>
                       </a:r>
@@ -6493,11 +6423,11 @@
                       <a:r>
                         <a:rPr lang="en-US" sz="700">
                           <a:solidFill>
-                            <a:srgbClr val="1B1F2A"/>
+                            <a:srgbClr val="000000"/>
                           </a:solidFill>
-                          <a:latin typeface="SB Sans Display Light"/>
-                          <a:ea typeface="SB Sans Display Light"/>
-                          <a:cs typeface="SB Sans Display Light"/>
+                          <a:latin typeface="SB Sans Text"/>
+                          <a:ea typeface="SB Sans Text"/>
+                          <a:cs typeface="SB Sans Text"/>
                         </a:rPr>
                         <a:t>Llama-8B / progr.</a:t>
                       </a:r>
@@ -6542,11 +6472,11 @@
                       <a:r>
                         <a:rPr lang="en-US" sz="700">
                           <a:solidFill>
-                            <a:srgbClr val="1B1F2A"/>
+                            <a:srgbClr val="000000"/>
                           </a:solidFill>
-                          <a:latin typeface="SB Sans Display Light"/>
-                          <a:ea typeface="SB Sans Display Light"/>
-                          <a:cs typeface="SB Sans Display Light"/>
+                          <a:latin typeface="SB Sans Text"/>
+                          <a:ea typeface="SB Sans Text"/>
+                          <a:cs typeface="SB Sans Text"/>
                         </a:rPr>
                         <a:t>1353</a:t>
                       </a:r>
@@ -6589,13 +6519,13 @@
                         <a:buNone/>
                       </a:pPr>
                       <a:r>
-                        <a:rPr lang="en-US" sz="700" b="1">
+                        <a:rPr lang="en-US" sz="700">
                           <a:solidFill>
                             <a:srgbClr val="1E9E53"/>
                           </a:solidFill>
-                          <a:latin typeface="SB Sans Display"/>
-                          <a:ea typeface="SB Sans Display"/>
-                          <a:cs typeface="SB Sans Display"/>
+                          <a:latin typeface="SB Sans Text"/>
+                          <a:ea typeface="SB Sans Text"/>
+                          <a:cs typeface="SB Sans Text"/>
                         </a:rPr>
                         <a:t>100%</a:t>
                       </a:r>
@@ -6638,13 +6568,13 @@
                         <a:buNone/>
                       </a:pPr>
                       <a:r>
-                        <a:rPr lang="en-US" sz="700" b="1">
+                        <a:rPr lang="en-US" sz="700">
                           <a:solidFill>
                             <a:srgbClr val="1E9E53"/>
                           </a:solidFill>
-                          <a:latin typeface="SB Sans Display"/>
-                          <a:ea typeface="SB Sans Display"/>
-                          <a:cs typeface="SB Sans Display"/>
+                          <a:latin typeface="SB Sans Text"/>
+                          <a:ea typeface="SB Sans Text"/>
+                          <a:cs typeface="SB Sans Text"/>
                         </a:rPr>
                         <a:t>89.8%</a:t>
                       </a:r>
@@ -6691,11 +6621,11 @@
                       <a:r>
                         <a:rPr lang="en-US" sz="700">
                           <a:solidFill>
-                            <a:srgbClr val="1B1F2A"/>
+                            <a:srgbClr val="000000"/>
                           </a:solidFill>
-                          <a:latin typeface="SB Sans Display Light"/>
-                          <a:ea typeface="SB Sans Display Light"/>
-                          <a:cs typeface="SB Sans Display Light"/>
+                          <a:latin typeface="SB Sans Text"/>
+                          <a:ea typeface="SB Sans Text"/>
+                          <a:cs typeface="SB Sans Text"/>
                         </a:rPr>
                         <a:t>Pythia / full</a:t>
                       </a:r>
@@ -6740,11 +6670,11 @@
                       <a:r>
                         <a:rPr lang="en-US" sz="700">
                           <a:solidFill>
-                            <a:srgbClr val="1B1F2A"/>
+                            <a:srgbClr val="000000"/>
                           </a:solidFill>
-                          <a:latin typeface="SB Sans Display Light"/>
-                          <a:ea typeface="SB Sans Display Light"/>
-                          <a:cs typeface="SB Sans Display Light"/>
+                          <a:latin typeface="SB Sans Text"/>
+                          <a:ea typeface="SB Sans Text"/>
+                          <a:cs typeface="SB Sans Text"/>
                         </a:rPr>
                         <a:t>512</a:t>
                       </a:r>
@@ -6789,11 +6719,11 @@
                       <a:r>
                         <a:rPr lang="en-US" sz="700">
                           <a:solidFill>
-                            <a:srgbClr val="1B1F2A"/>
+                            <a:srgbClr val="000000"/>
                           </a:solidFill>
-                          <a:latin typeface="SB Sans Display Light"/>
-                          <a:ea typeface="SB Sans Display Light"/>
-                          <a:cs typeface="SB Sans Display Light"/>
+                          <a:latin typeface="SB Sans Text"/>
+                          <a:ea typeface="SB Sans Text"/>
+                          <a:cs typeface="SB Sans Text"/>
                         </a:rPr>
                         <a:t>99.71%</a:t>
                       </a:r>
@@ -6840,9 +6770,9 @@
                           <a:solidFill>
                             <a:srgbClr val="C0392B"/>
                           </a:solidFill>
-                          <a:latin typeface="SB Sans Display Light"/>
-                          <a:ea typeface="SB Sans Display Light"/>
-                          <a:cs typeface="SB Sans Display Light"/>
+                          <a:latin typeface="SB Sans Text"/>
+                          <a:ea typeface="SB Sans Text"/>
+                          <a:cs typeface="SB Sans Text"/>
                         </a:rPr>
                         <a:t>44.2%</a:t>
                       </a:r>
@@ -6889,11 +6819,11 @@
                       <a:r>
                         <a:rPr lang="en-US" sz="700">
                           <a:solidFill>
-                            <a:srgbClr val="1B1F2A"/>
+                            <a:srgbClr val="000000"/>
                           </a:solidFill>
-                          <a:latin typeface="SB Sans Display Light"/>
-                          <a:ea typeface="SB Sans Display Light"/>
-                          <a:cs typeface="SB Sans Display Light"/>
+                          <a:latin typeface="SB Sans Text"/>
+                          <a:ea typeface="SB Sans Text"/>
+                          <a:cs typeface="SB Sans Text"/>
                         </a:rPr>
                         <a:t>Pythia / progr.</a:t>
                       </a:r>
@@ -6938,11 +6868,11 @@
                       <a:r>
                         <a:rPr lang="en-US" sz="700">
                           <a:solidFill>
-                            <a:srgbClr val="1B1F2A"/>
+                            <a:srgbClr val="000000"/>
                           </a:solidFill>
-                          <a:latin typeface="SB Sans Display Light"/>
-                          <a:ea typeface="SB Sans Display Light"/>
-                          <a:cs typeface="SB Sans Display Light"/>
+                          <a:latin typeface="SB Sans Text"/>
+                          <a:ea typeface="SB Sans Text"/>
+                          <a:cs typeface="SB Sans Text"/>
                         </a:rPr>
                         <a:t>390</a:t>
                       </a:r>
@@ -6985,13 +6915,13 @@
                         <a:buNone/>
                       </a:pPr>
                       <a:r>
-                        <a:rPr lang="en-US" sz="700" b="1">
+                        <a:rPr lang="en-US" sz="700">
                           <a:solidFill>
                             <a:srgbClr val="1E9E53"/>
                           </a:solidFill>
-                          <a:latin typeface="SB Sans Display"/>
-                          <a:ea typeface="SB Sans Display"/>
-                          <a:cs typeface="SB Sans Display"/>
+                          <a:latin typeface="SB Sans Text"/>
+                          <a:ea typeface="SB Sans Text"/>
+                          <a:cs typeface="SB Sans Text"/>
                         </a:rPr>
                         <a:t>100%</a:t>
                       </a:r>
@@ -7034,13 +6964,13 @@
                         <a:buNone/>
                       </a:pPr>
                       <a:r>
-                        <a:rPr lang="en-US" sz="700" b="1">
+                        <a:rPr lang="en-US" sz="700">
                           <a:solidFill>
                             <a:srgbClr val="1E9E53"/>
                           </a:solidFill>
-                          <a:latin typeface="SB Sans Display"/>
-                          <a:ea typeface="SB Sans Display"/>
-                          <a:cs typeface="SB Sans Display"/>
+                          <a:latin typeface="SB Sans Text"/>
+                          <a:ea typeface="SB Sans Text"/>
+                          <a:cs typeface="SB Sans Text"/>
                         </a:rPr>
                         <a:t>96.9%</a:t>
                       </a:r>
@@ -7072,14 +7002,14 @@
       </p:graphicFrame>
       <p:sp>
         <p:nvSpPr>
-          <p:cNvPr id="33" name="TextBox 32"/>
+          <p:cNvPr id="30" name="TextBox 29"/>
           <p:cNvSpPr txBox="1"/>
           <p:nvPr/>
         </p:nvSpPr>
         <p:spPr>
           <a:xfrm>
             <a:off x="466427" y="131415"/>
-            <a:ext cx="705755" cy="158353"/>
+            <a:ext cx="270700" cy="158353"/>
           </a:xfrm>
           <a:prstGeom prst="rect">
             <a:avLst/>
@@ -7113,7 +7043,7 @@
                 <a:ea typeface="SB Sans Display Semibold"/>
                 <a:cs typeface="SB Sans Display Semibold"/>
               </a:rPr>
-              <a:t>№TODO</a:t>
+              <a:t>№1</a:t>
             </a:r>
             <a:endParaRPr lang="en-US" sz="1300"/>
           </a:p>
@@ -7121,7 +7051,7 @@
       </p:sp>
       <p:sp>
         <p:nvSpPr>
-          <p:cNvPr id="34" name="TextBox 33"/>
+          <p:cNvPr id="31" name="TextBox 30"/>
           <p:cNvSpPr txBox="1"/>
           <p:nvPr/>
         </p:nvSpPr>
@@ -7170,7 +7100,7 @@
       </p:sp>
       <p:sp>
         <p:nvSpPr>
-          <p:cNvPr id="35" name="TextBox 34"/>
+          <p:cNvPr id="32" name="TextBox 31"/>
           <p:cNvSpPr txBox="1"/>
           <p:nvPr/>
         </p:nvSpPr>
@@ -7296,14 +7226,14 @@
       </p:sp>
       <p:sp>
         <p:nvSpPr>
-          <p:cNvPr id="36" name="TextBox 35"/>
+          <p:cNvPr id="33" name="TextBox 32"/>
           <p:cNvSpPr txBox="1"/>
           <p:nvPr/>
         </p:nvSpPr>
         <p:spPr>
           <a:xfrm>
-            <a:off x="466427" y="1367879"/>
-            <a:ext cx="2878912" cy="106561"/>
+            <a:off x="476250" y="1425476"/>
+            <a:ext cx="2826693" cy="213420"/>
           </a:xfrm>
           <a:prstGeom prst="rect">
             <a:avLst/>
@@ -7318,7 +7248,7 @@
           <a:p>
             <a:pPr algn="l">
               <a:lnSpc>
-                <a:spcPts val="840"/>
+                <a:spcPts val="1680"/>
               </a:lnSpc>
               <a:spcBef>
                 <a:spcPts val="0"/>
@@ -7329,7 +7259,7 @@
               <a:buNone/>
             </a:pPr>
             <a:r>
-              <a:rPr lang="en-US" sz="700" cap="all" spc="28">
+              <a:rPr lang="en-US" sz="1400" b="1">
                 <a:solidFill>
                   <a:srgbClr val="000000"/>
                 </a:solidFill>
@@ -7340,7 +7270,7 @@
               <a:t>1</a:t>
             </a:r>
             <a:r>
-              <a:rPr lang="en-US" sz="700" cap="all" spc="28">
+              <a:rPr lang="en-US" sz="1400" b="1">
                 <a:solidFill>
                   <a:srgbClr val="000000"/>
                 </a:solidFill>
@@ -7348,9 +7278,9 @@
                 <a:ea typeface="SB Sans Display"/>
                 <a:cs typeface="SB Sans Display"/>
               </a:rPr>
-              <a:t> Progressive cramming</a:t>
-            </a:r>
-            <a:endParaRPr lang="en-US" sz="700"/>
+              <a:t> Method</a:t>
+            </a:r>
+            <a:endParaRPr lang="en-US" sz="1400"/>
           </a:p>
         </p:txBody>
       </p:sp>
@@ -7358,14 +7288,14 @@
         <mc:Choice xmlns:a14="http://schemas.microsoft.com/office/drawing/2010/main" Requires="a14">
           <p:sp>
             <p:nvSpPr>
-              <p:cNvPr id="37" name="TextBox 36"/>
+              <p:cNvPr id="34" name="TextBox 33"/>
               <p:cNvSpPr txBox="1"/>
               <p:nvPr/>
             </p:nvSpPr>
             <p:spPr>
               <a:xfrm>
-                <a:off x="466427" y="1528316"/>
-                <a:ext cx="2878912" cy="333077"/>
+                <a:off x="476250" y="1692771"/>
+                <a:ext cx="2826693" cy="444103"/>
               </a:xfrm>
               <a:prstGeom prst="rect">
                 <a:avLst/>
@@ -7393,33 +7323,33 @@
                 <a:r>
                   <a:rPr lang="en-US" sz="700">
                     <a:solidFill>
-                      <a:srgbClr val="1B1F2A"/>
+                      <a:srgbClr val="000000"/>
                     </a:solidFill>
-                    <a:latin typeface="SB Sans Display Light"/>
-                    <a:ea typeface="SB Sans Display Light"/>
-                    <a:cs typeface="SB Sans Display Light"/>
+                    <a:latin typeface="SB Sans Text"/>
+                    <a:ea typeface="SB Sans Text"/>
+                    <a:cs typeface="SB Sans Text"/>
                   </a:rPr>
                   <a:t>Optimise a </a:t>
                 </a:r>
                 <a:r>
-                  <a:rPr lang="en-US" sz="700" b="1">
+                  <a:rPr lang="en-US" sz="700">
                     <a:solidFill>
-                      <a:srgbClr val="1B1F2A"/>
+                      <a:srgbClr val="000000"/>
                     </a:solidFill>
-                    <a:latin typeface="SB Sans Display"/>
-                    <a:ea typeface="SB Sans Display"/>
-                    <a:cs typeface="SB Sans Display"/>
+                    <a:latin typeface="SB Sans Text Semibold"/>
+                    <a:ea typeface="SB Sans Text Semibold"/>
+                    <a:cs typeface="SB Sans Text Semibold"/>
                   </a:rPr>
                   <a:t>per-sample</a:t>
                 </a:r>
                 <a:r>
                   <a:rPr lang="en-US" sz="700">
                     <a:solidFill>
-                      <a:srgbClr val="1B1F2A"/>
+                      <a:srgbClr val="000000"/>
                     </a:solidFill>
-                    <a:latin typeface="SB Sans Display Light"/>
-                    <a:ea typeface="SB Sans Display Light"/>
-                    <a:cs typeface="SB Sans Display Light"/>
+                    <a:latin typeface="SB Sans Text"/>
+                    <a:ea typeface="SB Sans Text"/>
+                    <a:cs typeface="SB Sans Text"/>
                   </a:rPr>
                   <a:t> input embedding </a:t>
                 </a:r>
@@ -7433,7 +7363,7 @@
                           </m:rPr>
                           <a:rPr lang="en-US" sz="700" b="1">
                             <a:solidFill>
-                              <a:srgbClr val="1B1F2A"/>
+                              <a:srgbClr val="000000"/>
                             </a:solidFill>
                             <a:latin typeface="Cambria Math" panose="02040503050406030204" pitchFamily="18" charset="0"/>
                             <a:cs typeface="Cambria Math" panose="02040503050406030204" pitchFamily="18" charset="0"/>
@@ -7447,11 +7377,11 @@
                 <a:r>
                   <a:rPr lang="en-US" sz="700">
                     <a:solidFill>
-                      <a:srgbClr val="1B1F2A"/>
+                      <a:srgbClr val="000000"/>
                     </a:solidFill>
-                    <a:latin typeface="SB Sans Display Light"/>
-                    <a:ea typeface="SB Sans Display Light"/>
-                    <a:cs typeface="SB Sans Display Light"/>
+                    <a:latin typeface="SB Sans Text"/>
+                    <a:ea typeface="SB Sans Text"/>
+                    <a:cs typeface="SB Sans Text"/>
                   </a:rPr>
                   <a:t> so that a </a:t>
                 </a:r>
@@ -7460,64 +7390,64 @@
                     <a:solidFill>
                       <a:srgbClr val="26359A"/>
                     </a:solidFill>
-                    <a:latin typeface="SB Sans Display"/>
-                    <a:ea typeface="SB Sans Display"/>
-                    <a:cs typeface="SB Sans Display"/>
+                    <a:latin typeface="SB Sans Text"/>
+                    <a:ea typeface="SB Sans Text"/>
+                    <a:cs typeface="SB Sans Text"/>
                   </a:rPr>
                   <a:t>frozen LM</a:t>
                 </a:r>
                 <a:r>
                   <a:rPr lang="en-US" sz="700">
                     <a:solidFill>
-                      <a:srgbClr val="1B1F2A"/>
+                      <a:srgbClr val="000000"/>
                     </a:solidFill>
-                    <a:latin typeface="SB Sans Display Light"/>
-                    <a:ea typeface="SB Sans Display Light"/>
-                    <a:cs typeface="SB Sans Display Light"/>
+                    <a:latin typeface="SB Sans Text"/>
+                    <a:ea typeface="SB Sans Text"/>
+                    <a:cs typeface="SB Sans Text"/>
                   </a:rPr>
                   <a:t> reconstructs a text. The target grows </a:t>
                 </a:r>
                 <a:r>
-                  <a:rPr lang="en-US" sz="700" b="1">
+                  <a:rPr lang="en-US" sz="700">
                     <a:solidFill>
-                      <a:srgbClr val="1B1F2A"/>
+                      <a:srgbClr val="000000"/>
                     </a:solidFill>
-                    <a:latin typeface="SB Sans Display"/>
-                    <a:ea typeface="SB Sans Display"/>
-                    <a:cs typeface="SB Sans Display"/>
+                    <a:latin typeface="SB Sans Text Semibold"/>
+                    <a:ea typeface="SB Sans Text Semibold"/>
+                    <a:cs typeface="SB Sans Text Semibold"/>
                   </a:rPr>
                   <a:t>one token at a time</a:t>
                 </a:r>
                 <a:r>
                   <a:rPr lang="en-US" sz="700">
                     <a:solidFill>
-                      <a:srgbClr val="1B1F2A"/>
+                      <a:srgbClr val="000000"/>
                     </a:solidFill>
-                    <a:latin typeface="SB Sans Display Light"/>
-                    <a:ea typeface="SB Sans Display Light"/>
-                    <a:cs typeface="SB Sans Display Light"/>
+                    <a:latin typeface="SB Sans Text"/>
+                    <a:ea typeface="SB Sans Text"/>
+                    <a:cs typeface="SB Sans Text"/>
                   </a:rPr>
                   <a:t>; the next stage starts only after </a:t>
                 </a:r>
                 <a:r>
-                  <a:rPr lang="en-US" sz="700" b="1">
+                  <a:rPr lang="en-US" sz="700">
                     <a:solidFill>
-                      <a:srgbClr val="1B1F2A"/>
+                      <a:srgbClr val="000000"/>
                     </a:solidFill>
-                    <a:latin typeface="SB Sans Display"/>
-                    <a:ea typeface="SB Sans Display"/>
-                    <a:cs typeface="SB Sans Display"/>
+                    <a:latin typeface="SB Sans Text Semibold"/>
+                    <a:ea typeface="SB Sans Text Semibold"/>
+                    <a:cs typeface="SB Sans Text Semibold"/>
                   </a:rPr>
                   <a:t>perfect</a:t>
                 </a:r>
                 <a:r>
                   <a:rPr lang="en-US" sz="700">
                     <a:solidFill>
-                      <a:srgbClr val="1B1F2A"/>
+                      <a:srgbClr val="000000"/>
                     </a:solidFill>
-                    <a:latin typeface="SB Sans Display Light"/>
-                    <a:ea typeface="SB Sans Display Light"/>
-                    <a:cs typeface="SB Sans Display Light"/>
+                    <a:latin typeface="SB Sans Text"/>
+                    <a:ea typeface="SB Sans Text"/>
+                    <a:cs typeface="SB Sans Text"/>
                   </a:rPr>
                   <a:t> greedy reconstruction of the current prefix.</a:t>
                 </a:r>
@@ -7529,20 +7459,20 @@
         <mc:Fallback>
           <p:sp>
             <p:nvSpPr>
-              <p:cNvPr id="37" name="TextBox 36"/>
+              <p:cNvPr id="34" name="TextBox 33"/>
               <p:cNvSpPr txBox="1"/>
               <p:nvPr/>
             </p:nvSpPr>
             <p:spPr>
               <a:xfrm>
-                <a:off x="466427" y="1528316"/>
-                <a:ext cx="2836366" cy="333077"/>
+                <a:off x="476250" y="1692771"/>
+                <a:ext cx="2826693" cy="444103"/>
               </a:xfrm>
               <a:prstGeom prst="rect">
                 <a:avLst/>
               </a:prstGeom>
               <a:blipFill>
-                <a:blip r:embed="rId16"/>
+                <a:blip r:embed="rId14"/>
                 <a:stretch>
                   <a:fillRect/>
                 </a:stretch>
@@ -7562,14 +7492,14 @@
         <mc:Choice xmlns:a14="http://schemas.microsoft.com/office/drawing/2010/main" Requires="a14">
           <p:sp>
             <p:nvSpPr>
-              <p:cNvPr id="38" name="TextBox 37"/>
+              <p:cNvPr id="35" name="TextBox 34"/>
               <p:cNvSpPr txBox="1"/>
               <p:nvPr/>
             </p:nvSpPr>
             <p:spPr>
               <a:xfrm>
-                <a:off x="466427" y="3000226"/>
-                <a:ext cx="2878912" cy="376238"/>
+                <a:off x="476250" y="3272135"/>
+                <a:ext cx="2826693" cy="487263"/>
               </a:xfrm>
               <a:prstGeom prst="rect">
                 <a:avLst/>
@@ -7598,11 +7528,11 @@
                 <a:r>
                   <a:rPr lang="en-US" sz="700">
                     <a:solidFill>
-                      <a:srgbClr val="1B1F2A"/>
+                      <a:srgbClr val="000000"/>
                     </a:solidFill>
-                    <a:latin typeface="SB Sans Display Light"/>
-                    <a:ea typeface="SB Sans Display Light"/>
-                    <a:cs typeface="SB Sans Display Light"/>
+                    <a:latin typeface="SB Sans Text"/>
+                    <a:ea typeface="SB Sans Text"/>
+                    <a:cs typeface="SB Sans Text"/>
                   </a:rPr>
                   <a:t>Halting on the first failure gives a </a:t>
                 </a:r>
@@ -7611,20 +7541,20 @@
                     <a:solidFill>
                       <a:srgbClr val="26359A"/>
                     </a:solidFill>
-                    <a:latin typeface="SB Sans Display"/>
-                    <a:ea typeface="SB Sans Display"/>
-                    <a:cs typeface="SB Sans Display"/>
+                    <a:latin typeface="SB Sans Text"/>
+                    <a:ea typeface="SB Sans Text"/>
+                    <a:cs typeface="SB Sans Text"/>
                   </a:rPr>
                   <a:t>sharp capacity boundary</a:t>
                 </a:r>
                 <a:r>
                   <a:rPr lang="en-US" sz="700">
                     <a:solidFill>
-                      <a:srgbClr val="1B1F2A"/>
+                      <a:srgbClr val="000000"/>
                     </a:solidFill>
-                    <a:latin typeface="SB Sans Display Light"/>
-                    <a:ea typeface="SB Sans Display Light"/>
-                    <a:cs typeface="SB Sans Display Light"/>
+                    <a:latin typeface="SB Sans Text"/>
+                    <a:ea typeface="SB Sans Text"/>
+                    <a:cs typeface="SB Sans Text"/>
                   </a:rPr>
                   <a:t> per sample.</a:t>
                 </a:r>
@@ -7649,20 +7579,20 @@
                     <a:solidFill>
                       <a:srgbClr val="26359A"/>
                     </a:solidFill>
-                    <a:latin typeface="SB Sans Display"/>
-                    <a:ea typeface="SB Sans Display"/>
-                    <a:cs typeface="SB Sans Display"/>
+                    <a:latin typeface="SB Sans Text"/>
+                    <a:ea typeface="SB Sans Text"/>
+                    <a:cs typeface="SB Sans Text"/>
                   </a:rPr>
                   <a:t>100% greedy reconstruction</a:t>
                 </a:r>
                 <a:r>
                   <a:rPr lang="en-US" sz="700">
                     <a:solidFill>
-                      <a:srgbClr val="1B1F2A"/>
+                      <a:srgbClr val="000000"/>
                     </a:solidFill>
-                    <a:latin typeface="SB Sans Display Light"/>
-                    <a:ea typeface="SB Sans Display Light"/>
-                    <a:cs typeface="SB Sans Display Light"/>
+                    <a:latin typeface="SB Sans Text"/>
+                    <a:ea typeface="SB Sans Text"/>
+                    <a:cs typeface="SB Sans Text"/>
                   </a:rPr>
                   <a:t> at every accepted stage.</a:t>
                 </a:r>
@@ -7685,11 +7615,11 @@
                 <a:r>
                   <a:rPr lang="en-US" sz="700">
                     <a:solidFill>
-                      <a:srgbClr val="1B1F2A"/>
+                      <a:srgbClr val="000000"/>
                     </a:solidFill>
-                    <a:latin typeface="SB Sans Display Light"/>
-                    <a:ea typeface="SB Sans Display Light"/>
-                    <a:cs typeface="SB Sans Display Light"/>
+                    <a:latin typeface="SB Sans Text"/>
+                    <a:ea typeface="SB Sans Text"/>
+                    <a:cs typeface="SB Sans Text"/>
                   </a:rPr>
                   <a:t>Saving </a:t>
                 </a:r>
@@ -7703,7 +7633,7 @@
                           </m:rPr>
                           <a:rPr lang="en-US" sz="700" b="1">
                             <a:solidFill>
-                              <a:srgbClr val="1B1F2A"/>
+                              <a:srgbClr val="000000"/>
                             </a:solidFill>
                             <a:latin typeface="Cambria Math" panose="02040503050406030204" pitchFamily="18" charset="0"/>
                             <a:cs typeface="Cambria Math" panose="02040503050406030204" pitchFamily="18" charset="0"/>
@@ -7717,11 +7647,11 @@
                 <a:r>
                   <a:rPr lang="en-US" sz="700">
                     <a:solidFill>
-                      <a:srgbClr val="1B1F2A"/>
+                      <a:srgbClr val="000000"/>
                     </a:solidFill>
-                    <a:latin typeface="SB Sans Display Light"/>
-                    <a:ea typeface="SB Sans Display Light"/>
-                    <a:cs typeface="SB Sans Display Light"/>
+                    <a:latin typeface="SB Sans Text"/>
+                    <a:ea typeface="SB Sans Text"/>
+                    <a:cs typeface="SB Sans Text"/>
                   </a:rPr>
                   <a:t> after each stage yields the </a:t>
                 </a:r>
@@ -7730,20 +7660,20 @@
                     <a:solidFill>
                       <a:srgbClr val="26359A"/>
                     </a:solidFill>
-                    <a:latin typeface="SB Sans Display"/>
-                    <a:ea typeface="SB Sans Display"/>
-                    <a:cs typeface="SB Sans Display"/>
+                    <a:latin typeface="SB Sans Text"/>
+                    <a:ea typeface="SB Sans Text"/>
+                    <a:cs typeface="SB Sans Text"/>
                   </a:rPr>
                   <a:t>optimisation trajectory</a:t>
                 </a:r>
                 <a:r>
                   <a:rPr lang="en-US" sz="700">
                     <a:solidFill>
-                      <a:srgbClr val="1B1F2A"/>
+                      <a:srgbClr val="000000"/>
                     </a:solidFill>
-                    <a:latin typeface="SB Sans Display Light"/>
-                    <a:ea typeface="SB Sans Display Light"/>
-                    <a:cs typeface="SB Sans Display Light"/>
+                    <a:latin typeface="SB Sans Text"/>
+                    <a:ea typeface="SB Sans Text"/>
+                    <a:cs typeface="SB Sans Text"/>
                   </a:rPr>
                   <a:t>.</a:t>
                 </a:r>
@@ -7755,20 +7685,20 @@
         <mc:Fallback>
           <p:sp>
             <p:nvSpPr>
-              <p:cNvPr id="38" name="TextBox 37"/>
+              <p:cNvPr id="35" name="TextBox 34"/>
               <p:cNvSpPr txBox="1"/>
               <p:nvPr/>
             </p:nvSpPr>
             <p:spPr>
               <a:xfrm>
-                <a:off x="466427" y="3000226"/>
-                <a:ext cx="2836366" cy="376238"/>
+                <a:off x="476250" y="3272135"/>
+                <a:ext cx="2826693" cy="487263"/>
               </a:xfrm>
               <a:prstGeom prst="rect">
                 <a:avLst/>
               </a:prstGeom>
               <a:blipFill>
-                <a:blip r:embed="rId17"/>
+                <a:blip r:embed="rId15"/>
                 <a:stretch>
                   <a:fillRect/>
                 </a:stretch>
@@ -7786,14 +7716,14 @@
       </mc:AlternateContent>
       <p:sp>
         <p:nvSpPr>
-          <p:cNvPr id="39" name="TextBox 38"/>
+          <p:cNvPr id="36" name="TextBox 35"/>
           <p:cNvSpPr txBox="1"/>
           <p:nvPr/>
         </p:nvSpPr>
         <p:spPr>
           <a:xfrm>
-            <a:off x="466427" y="3637806"/>
-            <a:ext cx="2878912" cy="106561"/>
+            <a:off x="476250" y="4020741"/>
+            <a:ext cx="2826693" cy="213420"/>
           </a:xfrm>
           <a:prstGeom prst="rect">
             <a:avLst/>
@@ -7808,7 +7738,7 @@
           <a:p>
             <a:pPr algn="l">
               <a:lnSpc>
-                <a:spcPts val="840"/>
+                <a:spcPts val="1680"/>
               </a:lnSpc>
               <a:spcBef>
                 <a:spcPts val="0"/>
@@ -7819,7 +7749,7 @@
               <a:buNone/>
             </a:pPr>
             <a:r>
-              <a:rPr lang="en-US" sz="700" cap="all" spc="28">
+              <a:rPr lang="en-US" sz="1400" b="1">
                 <a:solidFill>
                   <a:srgbClr val="000000"/>
                 </a:solidFill>
@@ -7830,7 +7760,7 @@
               <a:t>2</a:t>
             </a:r>
             <a:r>
-              <a:rPr lang="en-US" sz="700" cap="all" spc="28">
+              <a:rPr lang="en-US" sz="1400" b="1">
                 <a:solidFill>
                   <a:srgbClr val="000000"/>
                 </a:solidFill>
@@ -7838,22 +7768,22 @@
                 <a:ea typeface="SB Sans Display"/>
                 <a:cs typeface="SB Sans Display"/>
               </a:rPr>
-              <a:t> Across model families</a:t>
-            </a:r>
-            <a:endParaRPr lang="en-US" sz="700"/>
+              <a:t> Capacity</a:t>
+            </a:r>
+            <a:endParaRPr lang="en-US" sz="1400"/>
           </a:p>
         </p:txBody>
       </p:sp>
       <p:sp>
         <p:nvSpPr>
-          <p:cNvPr id="40" name="TextBox 39"/>
+          <p:cNvPr id="37" name="TextBox 36"/>
           <p:cNvSpPr txBox="1"/>
           <p:nvPr/>
         </p:nvSpPr>
         <p:spPr>
           <a:xfrm>
-            <a:off x="466427" y="3798243"/>
-            <a:ext cx="2878912" cy="222052"/>
+            <a:off x="476250" y="4288036"/>
+            <a:ext cx="2826693" cy="333077"/>
           </a:xfrm>
           <a:prstGeom prst="rect">
             <a:avLst/>
@@ -7881,37 +7811,86 @@
             <a:r>
               <a:rPr lang="en-US" sz="700">
                 <a:solidFill>
-                  <a:srgbClr val="1B1F2A"/>
+                  <a:srgbClr val="000000"/>
                 </a:solidFill>
-                <a:latin typeface="SB Sans Display Light"/>
-                <a:ea typeface="SB Sans Display Light"/>
-                <a:cs typeface="SB Sans Display Light"/>
+                <a:latin typeface="SB Sans Text"/>
+                <a:ea typeface="SB Sans Text"/>
+                <a:cs typeface="SB Sans Text"/>
               </a:rPr>
               <a:t>Longest text a frozen model reconstructs perfectly from a </a:t>
             </a:r>
             <a:r>
-              <a:rPr lang="en-US" sz="700" b="1">
+              <a:rPr lang="en-US" sz="700">
                 <a:solidFill>
-                  <a:srgbClr val="1B1F2A"/>
+                  <a:srgbClr val="000000"/>
                 </a:solidFill>
-                <a:latin typeface="SB Sans Display"/>
-                <a:ea typeface="SB Sans Display"/>
-                <a:cs typeface="SB Sans Display"/>
+                <a:latin typeface="SB Sans Text Semibold"/>
+                <a:ea typeface="SB Sans Text Semibold"/>
+                <a:cs typeface="SB Sans Text Semibold"/>
               </a:rPr>
               <a:t>single</a:t>
             </a:r>
             <a:r>
               <a:rPr lang="en-US" sz="700">
                 <a:solidFill>
-                  <a:srgbClr val="1B1F2A"/>
+                  <a:srgbClr val="000000"/>
                 </a:solidFill>
-                <a:latin typeface="SB Sans Display Light"/>
-                <a:ea typeface="SB Sans Display Light"/>
-                <a:cs typeface="SB Sans Display Light"/>
+                <a:latin typeface="SB Sans Text"/>
+                <a:ea typeface="SB Sans Text"/>
+                <a:cs typeface="SB Sans Text"/>
               </a:rPr>
               <a:t> embedding, with and without a low-dimensional projection:</a:t>
             </a:r>
             <a:endParaRPr lang="en-US" sz="700"/>
+          </a:p>
+        </p:txBody>
+      </p:sp>
+      <p:sp>
+        <p:nvSpPr>
+          <p:cNvPr id="38" name="TextBox 37"/>
+          <p:cNvSpPr txBox="1"/>
+          <p:nvPr/>
+        </p:nvSpPr>
+        <p:spPr>
+          <a:xfrm>
+            <a:off x="476250" y="5547717"/>
+            <a:ext cx="2826693" cy="152251"/>
+          </a:xfrm>
+          <a:prstGeom prst="rect">
+            <a:avLst/>
+          </a:prstGeom>
+          <a:noFill/>
+        </p:spPr>
+        <p:txBody>
+          <a:bodyPr wrap="none" lIns="0" rIns="0" tIns="0" bIns="0" anchor="t">
+            <a:noAutofit/>
+          </a:bodyPr>
+          <a:lstStyle/>
+          <a:p>
+            <a:pPr algn="l">
+              <a:lnSpc>
+                <a:spcPts val="1200"/>
+              </a:lnSpc>
+              <a:spcBef>
+                <a:spcPts val="0"/>
+              </a:spcBef>
+              <a:spcAft>
+                <a:spcPts val="0"/>
+              </a:spcAft>
+              <a:buNone/>
+            </a:pPr>
+            <a:r>
+              <a:rPr lang="en-US" sz="1000">
+                <a:solidFill>
+                  <a:srgbClr val="000000"/>
+                </a:solidFill>
+                <a:latin typeface="SB Sans Display Semibold"/>
+                <a:ea typeface="SB Sans Display Semibold"/>
+                <a:cs typeface="SB Sans Display Semibold"/>
+              </a:rPr>
+              <a:t>Low-dim projection</a:t>
+            </a:r>
+            <a:endParaRPr lang="en-US" sz="1000"/>
           </a:p>
         </p:txBody>
       </p:sp>
@@ -7919,14 +7898,14 @@
         <mc:Choice xmlns:a14="http://schemas.microsoft.com/office/drawing/2010/main" Requires="a14">
           <p:sp>
             <p:nvSpPr>
-              <p:cNvPr id="41" name="TextBox 40"/>
+              <p:cNvPr id="39" name="TextBox 38"/>
               <p:cNvSpPr txBox="1"/>
               <p:nvPr/>
             </p:nvSpPr>
             <p:spPr>
               <a:xfrm>
-                <a:off x="466427" y="4946898"/>
-                <a:ext cx="2878912" cy="111026"/>
+                <a:off x="476250" y="5753844"/>
+                <a:ext cx="2826693" cy="111026"/>
               </a:xfrm>
               <a:prstGeom prst="rect">
                 <a:avLst/>
@@ -7952,26 +7931,15 @@
                   <a:buNone/>
                 </a:pPr>
                 <a:r>
-                  <a:rPr lang="en-US" sz="700" b="1">
-                    <a:solidFill>
-                      <a:srgbClr val="1B1F2A"/>
-                    </a:solidFill>
-                    <a:latin typeface="SB Sans Display"/>
-                    <a:ea typeface="SB Sans Display"/>
-                    <a:cs typeface="SB Sans Display"/>
-                  </a:rPr>
-                  <a:t>Low-dim projection.</a:t>
-                </a:r>
-                <a:r>
                   <a:rPr lang="en-US" sz="700">
                     <a:solidFill>
-                      <a:srgbClr val="1B1F2A"/>
+                      <a:srgbClr val="000000"/>
                     </a:solidFill>
-                    <a:latin typeface="SB Sans Display Light"/>
-                    <a:ea typeface="SB Sans Display Light"/>
-                    <a:cs typeface="SB Sans Display Light"/>
+                    <a:latin typeface="SB Sans Text"/>
+                    <a:ea typeface="SB Sans Text"/>
+                    <a:cs typeface="SB Sans Text"/>
                   </a:rPr>
-                  <a:t> Optimise </a:t>
+                  <a:t>Optimise </a:t>
                 </a:r>
                 <a14:m>
                   <m:oMath xmlns:m="http://schemas.openxmlformats.org/officeDocument/2006/math">
@@ -7983,7 +7951,7 @@
                           </m:rPr>
                           <a:rPr lang="en-US" sz="700" b="1">
                             <a:solidFill>
-                              <a:srgbClr val="1B1F2A"/>
+                              <a:srgbClr val="000000"/>
                             </a:solidFill>
                             <a:latin typeface="Cambria Math" panose="02040503050406030204" pitchFamily="18" charset="0"/>
                             <a:cs typeface="Cambria Math" panose="02040503050406030204" pitchFamily="18" charset="0"/>
@@ -7997,11 +7965,11 @@
                 <a:r>
                   <a:rPr lang="en-US" sz="700">
                     <a:solidFill>
-                      <a:srgbClr val="1B1F2A"/>
+                      <a:srgbClr val="000000"/>
                     </a:solidFill>
-                    <a:latin typeface="SB Sans Display Light"/>
-                    <a:ea typeface="SB Sans Display Light"/>
-                    <a:cs typeface="SB Sans Display Light"/>
+                    <a:latin typeface="SB Sans Text"/>
+                    <a:ea typeface="SB Sans Text"/>
+                    <a:cs typeface="SB Sans Text"/>
                   </a:rPr>
                   <a:t> with a per-sample affine map </a:t>
                 </a:r>
@@ -8013,7 +7981,7 @@
                       </m:rPr>
                       <a:rPr lang="en-US" sz="700" i="1">
                         <a:solidFill>
-                          <a:srgbClr val="1B1F2A"/>
+                          <a:srgbClr val="000000"/>
                         </a:solidFill>
                         <a:latin typeface="Cambria Math" panose="02040503050406030204" pitchFamily="18" charset="0"/>
                         <a:cs typeface="Cambria Math" panose="02040503050406030204" pitchFamily="18" charset="0"/>
@@ -8026,7 +7994,7 @@
                       </m:rPr>
                       <a:rPr lang="en-US" sz="700">
                         <a:solidFill>
-                          <a:srgbClr val="1B1F2A"/>
+                          <a:srgbClr val="000000"/>
                         </a:solidFill>
                         <a:latin typeface="Cambria Math" panose="02040503050406030204" pitchFamily="18" charset="0"/>
                         <a:cs typeface="Cambria Math" panose="02040503050406030204" pitchFamily="18" charset="0"/>
@@ -8041,7 +8009,7 @@
                           </m:rPr>
                           <a:rPr lang="en-US" sz="700" b="1">
                             <a:solidFill>
-                              <a:srgbClr val="1B1F2A"/>
+                              <a:srgbClr val="000000"/>
                             </a:solidFill>
                             <a:latin typeface="Cambria Math" panose="02040503050406030204" pitchFamily="18" charset="0"/>
                             <a:cs typeface="Cambria Math" panose="02040503050406030204" pitchFamily="18" charset="0"/>
@@ -8055,11 +8023,11 @@
                 <a:r>
                   <a:rPr lang="en-US" sz="700">
                     <a:solidFill>
-                      <a:srgbClr val="1B1F2A"/>
+                      <a:srgbClr val="000000"/>
                     </a:solidFill>
-                    <a:latin typeface="SB Sans Display Light"/>
-                    <a:ea typeface="SB Sans Display Light"/>
-                    <a:cs typeface="SB Sans Display Light"/>
+                    <a:latin typeface="SB Sans Text"/>
+                    <a:ea typeface="SB Sans Text"/>
+                    <a:cs typeface="SB Sans Text"/>
                   </a:rPr>
                   <a:t>:</a:t>
                 </a:r>
@@ -8071,20 +8039,20 @@
         <mc:Fallback>
           <p:sp>
             <p:nvSpPr>
-              <p:cNvPr id="41" name="TextBox 40"/>
+              <p:cNvPr id="39" name="TextBox 38"/>
               <p:cNvSpPr txBox="1"/>
               <p:nvPr/>
             </p:nvSpPr>
             <p:spPr>
               <a:xfrm>
-                <a:off x="466427" y="4946898"/>
-                <a:ext cx="2836366" cy="111026"/>
+                <a:off x="476250" y="5753844"/>
+                <a:ext cx="2826693" cy="111026"/>
               </a:xfrm>
               <a:prstGeom prst="rect">
                 <a:avLst/>
               </a:prstGeom>
               <a:blipFill>
-                <a:blip r:embed="rId18"/>
+                <a:blip r:embed="rId16"/>
                 <a:stretch>
                   <a:fillRect/>
                 </a:stretch>
@@ -8102,14 +8070,14 @@
       </mc:AlternateContent>
       <p:sp>
         <p:nvSpPr>
-          <p:cNvPr id="42" name="TextBox 41"/>
+          <p:cNvPr id="40" name="TextBox 39"/>
           <p:cNvSpPr txBox="1"/>
           <p:nvPr/>
         </p:nvSpPr>
         <p:spPr>
           <a:xfrm>
-            <a:off x="466427" y="6758285"/>
-            <a:ext cx="2878912" cy="106561"/>
+            <a:off x="476250" y="6570762"/>
+            <a:ext cx="2826693" cy="213420"/>
           </a:xfrm>
           <a:prstGeom prst="rect">
             <a:avLst/>
@@ -8124,7 +8092,7 @@
           <a:p>
             <a:pPr algn="l">
               <a:lnSpc>
-                <a:spcPts val="840"/>
+                <a:spcPts val="1680"/>
               </a:lnSpc>
               <a:spcBef>
                 <a:spcPts val="0"/>
@@ -8135,7 +8103,7 @@
               <a:buNone/>
             </a:pPr>
             <a:r>
-              <a:rPr lang="en-US" sz="700" cap="all" spc="28">
+              <a:rPr lang="en-US" sz="1400" b="1">
                 <a:solidFill>
                   <a:srgbClr val="000000"/>
                 </a:solidFill>
@@ -8146,7 +8114,7 @@
               <a:t>3</a:t>
             </a:r>
             <a:r>
-              <a:rPr lang="en-US" sz="700" cap="all" spc="28">
+              <a:rPr lang="en-US" sz="1400" b="1">
                 <a:solidFill>
                   <a:srgbClr val="000000"/>
                 </a:solidFill>
@@ -8154,9 +8122,9 @@
                 <a:ea typeface="SB Sans Display"/>
                 <a:cs typeface="SB Sans Display"/>
               </a:rPr>
-              <a:t> Optimisation trajectories</a:t>
-            </a:r>
-            <a:endParaRPr lang="en-US" sz="700"/>
+              <a:t> Trajectories</a:t>
+            </a:r>
+            <a:endParaRPr lang="en-US" sz="1400"/>
           </a:p>
         </p:txBody>
       </p:sp>
@@ -8164,14 +8132,14 @@
         <mc:Choice xmlns:a14="http://schemas.microsoft.com/office/drawing/2010/main" Requires="a14">
           <p:sp>
             <p:nvSpPr>
-              <p:cNvPr id="43" name="TextBox 42"/>
+              <p:cNvPr id="41" name="TextBox 40"/>
               <p:cNvSpPr txBox="1"/>
               <p:nvPr/>
             </p:nvSpPr>
             <p:spPr>
               <a:xfrm>
-                <a:off x="466427" y="6918722"/>
-                <a:ext cx="2878912" cy="467916"/>
+                <a:off x="476250" y="6838057"/>
+                <a:ext cx="2826693" cy="591741"/>
               </a:xfrm>
               <a:prstGeom prst="rect">
                 <a:avLst/>
@@ -8200,11 +8168,11 @@
                 <a:r>
                   <a:rPr lang="en-US" sz="700">
                     <a:solidFill>
-                      <a:srgbClr val="1B1F2A"/>
+                      <a:srgbClr val="000000"/>
                     </a:solidFill>
-                    <a:latin typeface="SB Sans Display Light"/>
-                    <a:ea typeface="SB Sans Display Light"/>
-                    <a:cs typeface="SB Sans Display Light"/>
+                    <a:latin typeface="SB Sans Text"/>
+                    <a:ea typeface="SB Sans Text"/>
+                    <a:cs typeface="SB Sans Text"/>
                   </a:rPr>
                   <a:t>Trajectories are </a:t>
                 </a:r>
@@ -8213,20 +8181,20 @@
                     <a:solidFill>
                       <a:srgbClr val="26359A"/>
                     </a:solidFill>
-                    <a:latin typeface="SB Sans Display"/>
-                    <a:ea typeface="SB Sans Display"/>
-                    <a:cs typeface="SB Sans Display"/>
+                    <a:latin typeface="SB Sans Text"/>
+                    <a:ea typeface="SB Sans Text"/>
+                    <a:cs typeface="SB Sans Text"/>
                   </a:rPr>
                   <a:t>intrinsically low-dimensional</a:t>
                 </a:r>
                 <a:r>
                   <a:rPr lang="en-US" sz="700">
                     <a:solidFill>
-                      <a:srgbClr val="1B1F2A"/>
+                      <a:srgbClr val="000000"/>
                     </a:solidFill>
-                    <a:latin typeface="SB Sans Display Light"/>
-                    <a:ea typeface="SB Sans Display Light"/>
-                    <a:cs typeface="SB Sans Display Light"/>
+                    <a:latin typeface="SB Sans Text"/>
+                    <a:ea typeface="SB Sans Text"/>
+                    <a:cs typeface="SB Sans Text"/>
                   </a:rPr>
                   <a:t>: 30–100 PCA components explain 99% of the variance, although they live in </a:t>
                 </a:r>
@@ -8243,7 +8211,7 @@
                               </m:rPr>
                               <a:rPr lang="en-US" sz="700" i="1">
                                 <a:solidFill>
-                                  <a:srgbClr val="1B1F2A"/>
+                                  <a:srgbClr val="000000"/>
                                 </a:solidFill>
                                 <a:latin typeface="Cambria Math" panose="02040503050406030204" pitchFamily="18" charset="0"/>
                                 <a:cs typeface="Cambria Math" panose="02040503050406030204" pitchFamily="18" charset="0"/>
@@ -8262,7 +8230,7 @@
                               </m:rPr>
                               <a:rPr lang="en-US" sz="700">
                                 <a:solidFill>
-                                  <a:srgbClr val="1B1F2A"/>
+                                  <a:srgbClr val="000000"/>
                                 </a:solidFill>
                                 <a:latin typeface="Cambria Math" panose="02040503050406030204" pitchFamily="18" charset="0"/>
                                 <a:cs typeface="Cambria Math" panose="02040503050406030204" pitchFamily="18" charset="0"/>
@@ -8278,11 +8246,11 @@
                 <a:r>
                   <a:rPr lang="en-US" sz="700">
                     <a:solidFill>
-                      <a:srgbClr val="1B1F2A"/>
+                      <a:srgbClr val="000000"/>
                     </a:solidFill>
-                    <a:latin typeface="SB Sans Display Light"/>
-                    <a:ea typeface="SB Sans Display Light"/>
-                    <a:cs typeface="SB Sans Display Light"/>
+                    <a:latin typeface="SB Sans Text"/>
+                    <a:ea typeface="SB Sans Text"/>
+                    <a:cs typeface="SB Sans Text"/>
                   </a:rPr>
                   <a:t>.</a:t>
                 </a:r>
@@ -8305,11 +8273,11 @@
                 <a:r>
                   <a:rPr lang="en-US" sz="700">
                     <a:solidFill>
-                      <a:srgbClr val="1B1F2A"/>
+                      <a:srgbClr val="000000"/>
                     </a:solidFill>
-                    <a:latin typeface="SB Sans Display Light"/>
-                    <a:ea typeface="SB Sans Display Light"/>
-                    <a:cs typeface="SB Sans Display Light"/>
+                    <a:latin typeface="SB Sans Text"/>
+                    <a:ea typeface="SB Sans Text"/>
+                    <a:cs typeface="SB Sans Text"/>
                   </a:rPr>
                   <a:t>Accuracy basins </a:t>
                 </a:r>
@@ -8318,20 +8286,20 @@
                     <a:solidFill>
                       <a:srgbClr val="26359A"/>
                     </a:solidFill>
-                    <a:latin typeface="SB Sans Display"/>
-                    <a:ea typeface="SB Sans Display"/>
-                    <a:cs typeface="SB Sans Display"/>
+                    <a:latin typeface="SB Sans Text"/>
+                    <a:ea typeface="SB Sans Text"/>
+                    <a:cs typeface="SB Sans Text"/>
                   </a:rPr>
                   <a:t>shrink</a:t>
                 </a:r>
                 <a:r>
                   <a:rPr lang="en-US" sz="700">
                     <a:solidFill>
-                      <a:srgbClr val="1B1F2A"/>
+                      <a:srgbClr val="000000"/>
                     </a:solidFill>
-                    <a:latin typeface="SB Sans Display Light"/>
-                    <a:ea typeface="SB Sans Display Light"/>
-                    <a:cs typeface="SB Sans Display Light"/>
+                    <a:latin typeface="SB Sans Text"/>
+                    <a:ea typeface="SB Sans Text"/>
+                    <a:cs typeface="SB Sans Text"/>
                   </a:rPr>
                   <a:t> with sequence length — longer texts leave less room for error.</a:t>
                 </a:r>
@@ -8343,20 +8311,20 @@
         <mc:Fallback>
           <p:sp>
             <p:nvSpPr>
-              <p:cNvPr id="43" name="TextBox 42"/>
+              <p:cNvPr id="41" name="TextBox 40"/>
               <p:cNvSpPr txBox="1"/>
               <p:nvPr/>
             </p:nvSpPr>
             <p:spPr>
               <a:xfrm>
-                <a:off x="466427" y="6918722"/>
-                <a:ext cx="2836366" cy="467916"/>
+                <a:off x="476250" y="6838057"/>
+                <a:ext cx="2826693" cy="591741"/>
               </a:xfrm>
               <a:prstGeom prst="rect">
                 <a:avLst/>
               </a:prstGeom>
               <a:blipFill>
-                <a:blip r:embed="rId19"/>
+                <a:blip r:embed="rId17"/>
                 <a:stretch>
                   <a:fillRect/>
                 </a:stretch>
@@ -8374,14 +8342,14 @@
       </mc:AlternateContent>
       <p:sp>
         <p:nvSpPr>
-          <p:cNvPr id="44" name="TextBox 43"/>
+          <p:cNvPr id="42" name="TextBox 41"/>
           <p:cNvSpPr txBox="1"/>
           <p:nvPr/>
         </p:nvSpPr>
         <p:spPr>
           <a:xfrm>
-            <a:off x="466427" y="8672215"/>
-            <a:ext cx="2878912" cy="222052"/>
+            <a:off x="476250" y="8645128"/>
+            <a:ext cx="2826693" cy="222052"/>
           </a:xfrm>
           <a:prstGeom prst="rect">
             <a:avLst/>
@@ -8407,26 +8375,157 @@
               <a:buNone/>
             </a:pPr>
             <a:r>
-              <a:rPr lang="en-US" sz="700" b="1">
+              <a:rPr lang="en-US" sz="700">
                 <a:solidFill>
-                  <a:srgbClr val="5A6275"/>
+                  <a:srgbClr val="000000"/>
+                </a:solidFill>
+                <a:latin typeface="SB Sans Text"/>
+                <a:ea typeface="SB Sans Text"/>
+                <a:cs typeface="SB Sans Text"/>
+              </a:rPr>
+              <a:t>Llama-3.1-8B</a:t>
+            </a:r>
+            <a:r>
+              <a:rPr lang="en-US" sz="700">
+                <a:solidFill>
+                  <a:srgbClr val="000000"/>
+                </a:solidFill>
+                <a:latin typeface="SB Sans Text"/>
+                <a:ea typeface="SB Sans Text"/>
+                <a:cs typeface="SB Sans Text"/>
+              </a:rPr>
+              <a:t> trajectory on PC1–PC2 (65.7% of variance); coloured regions are local accuracy basins.</a:t>
+            </a:r>
+            <a:endParaRPr lang="en-US" sz="700"/>
+          </a:p>
+        </p:txBody>
+      </p:sp>
+      <p:sp>
+        <p:nvSpPr>
+          <p:cNvPr id="43" name="TextBox 42"/>
+          <p:cNvSpPr txBox="1"/>
+          <p:nvPr/>
+        </p:nvSpPr>
+        <p:spPr>
+          <a:xfrm>
+            <a:off x="3554909" y="1425476"/>
+            <a:ext cx="2826841" cy="213420"/>
+          </a:xfrm>
+          <a:prstGeom prst="rect">
+            <a:avLst/>
+          </a:prstGeom>
+          <a:noFill/>
+        </p:spPr>
+        <p:txBody>
+          <a:bodyPr wrap="none" lIns="0" rIns="0" tIns="0" bIns="0" anchor="t">
+            <a:noAutofit/>
+          </a:bodyPr>
+          <a:lstStyle/>
+          <a:p>
+            <a:pPr algn="l">
+              <a:lnSpc>
+                <a:spcPts val="1680"/>
+              </a:lnSpc>
+              <a:spcBef>
+                <a:spcPts val="0"/>
+              </a:spcBef>
+              <a:spcAft>
+                <a:spcPts val="0"/>
+              </a:spcAft>
+              <a:buNone/>
+            </a:pPr>
+            <a:r>
+              <a:rPr lang="en-US" sz="1400" b="1">
+                <a:solidFill>
+                  <a:srgbClr val="000000"/>
                 </a:solidFill>
                 <a:latin typeface="SB Sans Display"/>
                 <a:ea typeface="SB Sans Display"/>
                 <a:cs typeface="SB Sans Display"/>
               </a:rPr>
-              <a:t>Llama-3.1-8B</a:t>
-            </a:r>
+              <a:t>4</a:t>
+            </a:r>
+            <a:r>
+              <a:rPr lang="en-US" sz="1400" b="1">
+                <a:solidFill>
+                  <a:srgbClr val="000000"/>
+                </a:solidFill>
+                <a:latin typeface="SB Sans Display"/>
+                <a:ea typeface="SB Sans Display"/>
+                <a:cs typeface="SB Sans Display"/>
+              </a:rPr>
+              <a:t> Understanding</a:t>
+            </a:r>
+            <a:endParaRPr lang="en-US" sz="1400"/>
+          </a:p>
+        </p:txBody>
+      </p:sp>
+      <p:sp>
+        <p:nvSpPr>
+          <p:cNvPr id="44" name="TextBox 43"/>
+          <p:cNvSpPr txBox="1"/>
+          <p:nvPr/>
+        </p:nvSpPr>
+        <p:spPr>
+          <a:xfrm>
+            <a:off x="3554909" y="2212181"/>
+            <a:ext cx="2826841" cy="222052"/>
+          </a:xfrm>
+          <a:prstGeom prst="rect">
+            <a:avLst/>
+          </a:prstGeom>
+          <a:noFill/>
+        </p:spPr>
+        <p:txBody>
+          <a:bodyPr wrap="square" lIns="0" rIns="0" tIns="0" bIns="0" anchor="t">
+            <a:noAutofit/>
+          </a:bodyPr>
+          <a:lstStyle/>
+          <a:p>
+            <a:pPr algn="l">
+              <a:lnSpc>
+                <a:spcPts val="875"/>
+              </a:lnSpc>
+              <a:spcBef>
+                <a:spcPts val="0"/>
+              </a:spcBef>
+              <a:spcAft>
+                <a:spcPts val="0"/>
+              </a:spcAft>
+              <a:buNone/>
+            </a:pPr>
             <a:r>
               <a:rPr lang="en-US" sz="700">
                 <a:solidFill>
-                  <a:srgbClr val="5A6275"/>
+                  <a:srgbClr val="000000"/>
                 </a:solidFill>
-                <a:latin typeface="SB Sans Display Light"/>
-                <a:ea typeface="SB Sans Display Light"/>
-                <a:cs typeface="SB Sans Display Light"/>
+                <a:latin typeface="SB Sans Text"/>
+                <a:ea typeface="SB Sans Text"/>
+                <a:cs typeface="SB Sans Text"/>
               </a:rPr>
-              <a:t> trajectory on PC1–PC2 (65.7% of variance); coloured regions are local accuracy basins.</a:t>
+              <a:t>Prepending a crammed embedding </a:t>
+            </a:r>
+            <a:r>
+              <a:rPr lang="en-US" sz="700">
+                <a:solidFill>
+                  <a:srgbClr val="C0392B"/>
+                </a:solidFill>
+                <a:latin typeface="SB Sans Text"/>
+                <a:ea typeface="SB Sans Text"/>
+                <a:cs typeface="SB Sans Text"/>
+              </a:rPr>
+              <a:t>drops</a:t>
+            </a:r>
+            <a:r>
+              <a:rPr lang="en-US" sz="700">
+                <a:solidFill>
+                  <a:srgbClr val="000000"/>
+                </a:solidFill>
+                <a:latin typeface="SB Sans Text"/>
+                <a:ea typeface="SB Sans Text"/>
+                <a:cs typeface="SB Sans Text"/>
+              </a:rPr>
+              <a:t> benchmark accuracy even with the original prefix in context:</a:t>
             </a:r>
             <a:endParaRPr lang="en-US" sz="700"/>
           </a:p>
@@ -8440,8 +8539,101 @@
         </p:nvSpPr>
         <p:spPr>
           <a:xfrm>
-            <a:off x="3554760" y="1367879"/>
-            <a:ext cx="2879063" cy="106561"/>
+            <a:off x="3554909" y="3197126"/>
+            <a:ext cx="2826841" cy="333077"/>
+          </a:xfrm>
+          <a:prstGeom prst="rect">
+            <a:avLst/>
+          </a:prstGeom>
+          <a:noFill/>
+        </p:spPr>
+        <p:txBody>
+          <a:bodyPr wrap="square" lIns="0" rIns="0" tIns="0" bIns="0" anchor="t">
+            <a:noAutofit/>
+          </a:bodyPr>
+          <a:lstStyle/>
+          <a:p>
+            <a:pPr algn="l">
+              <a:lnSpc>
+                <a:spcPts val="875"/>
+              </a:lnSpc>
+              <a:spcBef>
+                <a:spcPts val="0"/>
+              </a:spcBef>
+              <a:spcAft>
+                <a:spcPts val="0"/>
+              </a:spcAft>
+              <a:buNone/>
+            </a:pPr>
+            <a:r>
+              <a:rPr lang="en-US" sz="700">
+                <a:solidFill>
+                  <a:srgbClr val="000000"/>
+                </a:solidFill>
+                <a:latin typeface="SB Sans Text"/>
+                <a:ea typeface="SB Sans Text"/>
+                <a:cs typeface="SB Sans Text"/>
+              </a:rPr>
+              <a:t>On </a:t>
+            </a:r>
+            <a:r>
+              <a:rPr lang="en-US" sz="700">
+                <a:solidFill>
+                  <a:srgbClr val="000000"/>
+                </a:solidFill>
+                <a:latin typeface="SB Sans Text Semibold"/>
+                <a:ea typeface="SB Sans Text Semibold"/>
+                <a:cs typeface="SB Sans Text Semibold"/>
+              </a:rPr>
+              <a:t>generative 5-shot MMLU</a:t>
+            </a:r>
+            <a:r>
+              <a:rPr lang="en-US" sz="700">
+                <a:solidFill>
+                  <a:srgbClr val="000000"/>
+                </a:solidFill>
+                <a:latin typeface="SB Sans Text"/>
+                <a:ea typeface="SB Sans Text"/>
+                <a:cs typeface="SB Sans Text"/>
+              </a:rPr>
+              <a:t> accuracy falls to </a:t>
+            </a:r>
+            <a:r>
+              <a:rPr lang="en-US" sz="700">
+                <a:solidFill>
+                  <a:srgbClr val="C0392B"/>
+                </a:solidFill>
+                <a:latin typeface="SB Sans Text"/>
+                <a:ea typeface="SB Sans Text"/>
+                <a:cs typeface="SB Sans Text"/>
+              </a:rPr>
+              <a:t>≈0%</a:t>
+            </a:r>
+            <a:r>
+              <a:rPr lang="en-US" sz="700">
+                <a:solidFill>
+                  <a:srgbClr val="000000"/>
+                </a:solidFill>
+                <a:latin typeface="SB Sans Text"/>
+                <a:ea typeface="SB Sans Text"/>
+                <a:cs typeface="SB Sans Text"/>
+              </a:rPr>
+              <a:t> with the optimised embedding, while a random-embedding control stays at the baseline.</a:t>
+            </a:r>
+            <a:endParaRPr lang="en-US" sz="700"/>
+          </a:p>
+        </p:txBody>
+      </p:sp>
+      <p:sp>
+        <p:nvSpPr>
+          <p:cNvPr id="46" name="TextBox 45"/>
+          <p:cNvSpPr txBox="1"/>
+          <p:nvPr/>
+        </p:nvSpPr>
+        <p:spPr>
+          <a:xfrm>
+            <a:off x="3554909" y="3791545"/>
+            <a:ext cx="2826841" cy="213420"/>
           </a:xfrm>
           <a:prstGeom prst="rect">
             <a:avLst/>
@@ -8450,6 +8642,361 @@
         </p:spPr>
         <p:txBody>
           <a:bodyPr wrap="none" lIns="0" rIns="0" tIns="0" bIns="0" anchor="t">
+            <a:noAutofit/>
+          </a:bodyPr>
+          <a:lstStyle/>
+          <a:p>
+            <a:pPr algn="l">
+              <a:lnSpc>
+                <a:spcPts val="1680"/>
+              </a:lnSpc>
+              <a:spcBef>
+                <a:spcPts val="0"/>
+              </a:spcBef>
+              <a:spcAft>
+                <a:spcPts val="0"/>
+              </a:spcAft>
+              <a:buNone/>
+            </a:pPr>
+            <a:r>
+              <a:rPr lang="en-US" sz="1400" b="1">
+                <a:solidFill>
+                  <a:srgbClr val="000000"/>
+                </a:solidFill>
+                <a:latin typeface="SB Sans Display"/>
+                <a:ea typeface="SB Sans Display"/>
+                <a:cs typeface="SB Sans Display"/>
+              </a:rPr>
+              <a:t>5</a:t>
+            </a:r>
+            <a:r>
+              <a:rPr lang="en-US" sz="1400" b="1">
+                <a:solidFill>
+                  <a:srgbClr val="000000"/>
+                </a:solidFill>
+                <a:latin typeface="SB Sans Display"/>
+                <a:ea typeface="SB Sans Display"/>
+                <a:cs typeface="SB Sans Display"/>
+              </a:rPr>
+              <a:t> Attention knockout</a:t>
+            </a:r>
+            <a:endParaRPr lang="en-US" sz="1400"/>
+          </a:p>
+        </p:txBody>
+      </p:sp>
+      <p:sp>
+        <p:nvSpPr>
+          <p:cNvPr id="47" name="TextBox 46"/>
+          <p:cNvSpPr txBox="1"/>
+          <p:nvPr/>
+        </p:nvSpPr>
+        <p:spPr>
+          <a:xfrm>
+            <a:off x="3554909" y="4998690"/>
+            <a:ext cx="2826841" cy="333077"/>
+          </a:xfrm>
+          <a:prstGeom prst="rect">
+            <a:avLst/>
+          </a:prstGeom>
+          <a:noFill/>
+        </p:spPr>
+        <p:txBody>
+          <a:bodyPr wrap="square" lIns="0" rIns="0" tIns="0" bIns="0" anchor="t">
+            <a:noAutofit/>
+          </a:bodyPr>
+          <a:lstStyle/>
+          <a:p>
+            <a:pPr algn="l">
+              <a:lnSpc>
+                <a:spcPts val="875"/>
+              </a:lnSpc>
+              <a:spcBef>
+                <a:spcPts val="0"/>
+              </a:spcBef>
+              <a:spcAft>
+                <a:spcPts val="0"/>
+              </a:spcAft>
+              <a:buNone/>
+            </a:pPr>
+            <a:r>
+              <a:rPr lang="en-US" sz="700">
+                <a:solidFill>
+                  <a:srgbClr val="000000"/>
+                </a:solidFill>
+                <a:latin typeface="SB Sans Text"/>
+                <a:ea typeface="SB Sans Text"/>
+                <a:cs typeface="SB Sans Text"/>
+              </a:rPr>
+              <a:t>Llama-3.1-8B.</a:t>
+            </a:r>
+            <a:r>
+              <a:rPr lang="en-US" sz="700">
+                <a:solidFill>
+                  <a:srgbClr val="000000"/>
+                </a:solidFill>
+                <a:latin typeface="SB Sans Text"/>
+                <a:ea typeface="SB Sans Text"/>
+                <a:cs typeface="SB Sans Text"/>
+              </a:rPr>
+              <a:t> Forward knockout (masking early layers first) restores downstream accuracy, while reverse knockout fails until the early layers are masked too.</a:t>
+            </a:r>
+            <a:endParaRPr lang="en-US" sz="700"/>
+          </a:p>
+        </p:txBody>
+      </p:sp>
+      <p:sp>
+        <p:nvSpPr>
+          <p:cNvPr id="48" name="TextBox 47"/>
+          <p:cNvSpPr txBox="1"/>
+          <p:nvPr/>
+        </p:nvSpPr>
+        <p:spPr>
+          <a:xfrm>
+            <a:off x="3554909" y="5385643"/>
+            <a:ext cx="2826841" cy="444103"/>
+          </a:xfrm>
+          <a:prstGeom prst="rect">
+            <a:avLst/>
+          </a:prstGeom>
+          <a:noFill/>
+        </p:spPr>
+        <p:txBody>
+          <a:bodyPr wrap="square" lIns="0" rIns="0" tIns="0" bIns="0" anchor="t">
+            <a:noAutofit/>
+          </a:bodyPr>
+          <a:lstStyle/>
+          <a:p>
+            <a:pPr algn="l">
+              <a:lnSpc>
+                <a:spcPts val="875"/>
+              </a:lnSpc>
+              <a:spcBef>
+                <a:spcPts val="0"/>
+              </a:spcBef>
+              <a:spcAft>
+                <a:spcPts val="0"/>
+              </a:spcAft>
+              <a:buNone/>
+            </a:pPr>
+            <a:r>
+              <a:rPr lang="en-US" sz="700">
+                <a:solidFill>
+                  <a:srgbClr val="26359A"/>
+                </a:solidFill>
+                <a:latin typeface="SB Sans Text"/>
+                <a:ea typeface="SB Sans Text"/>
+                <a:cs typeface="SB Sans Text"/>
+              </a:rPr>
+              <a:t>Early layers</a:t>
+            </a:r>
+            <a:r>
+              <a:rPr lang="en-US" sz="700">
+                <a:solidFill>
+                  <a:srgbClr val="000000"/>
+                </a:solidFill>
+                <a:latin typeface="SB Sans Text"/>
+                <a:ea typeface="SB Sans Text"/>
+                <a:cs typeface="SB Sans Text"/>
+              </a:rPr>
+              <a:t> drive both the reconstruction and the capability collapse; the 20–60% late-layer attention mass is a symptom. The pattern holds for Llama-3.1-8B, Pythia-1.4B and SmolLM2-1.7B.</a:t>
+            </a:r>
+            <a:endParaRPr lang="en-US" sz="700"/>
+          </a:p>
+        </p:txBody>
+      </p:sp>
+      <p:sp>
+        <p:nvSpPr>
+          <p:cNvPr id="49" name="TextBox 48"/>
+          <p:cNvSpPr txBox="1"/>
+          <p:nvPr/>
+        </p:nvSpPr>
+        <p:spPr>
+          <a:xfrm>
+            <a:off x="3554909" y="6091089"/>
+            <a:ext cx="2826841" cy="213420"/>
+          </a:xfrm>
+          <a:prstGeom prst="rect">
+            <a:avLst/>
+          </a:prstGeom>
+          <a:noFill/>
+        </p:spPr>
+        <p:txBody>
+          <a:bodyPr wrap="none" lIns="0" rIns="0" tIns="0" bIns="0" anchor="t">
+            <a:noAutofit/>
+          </a:bodyPr>
+          <a:lstStyle/>
+          <a:p>
+            <a:pPr algn="l">
+              <a:lnSpc>
+                <a:spcPts val="1680"/>
+              </a:lnSpc>
+              <a:spcBef>
+                <a:spcPts val="0"/>
+              </a:spcBef>
+              <a:spcAft>
+                <a:spcPts val="0"/>
+              </a:spcAft>
+              <a:buNone/>
+            </a:pPr>
+            <a:r>
+              <a:rPr lang="en-US" sz="1400" b="1">
+                <a:solidFill>
+                  <a:srgbClr val="000000"/>
+                </a:solidFill>
+                <a:latin typeface="SB Sans Display"/>
+                <a:ea typeface="SB Sans Display"/>
+                <a:cs typeface="SB Sans Display"/>
+              </a:rPr>
+              <a:t>6</a:t>
+            </a:r>
+            <a:r>
+              <a:rPr lang="en-US" sz="1400" b="1">
+                <a:solidFill>
+                  <a:srgbClr val="000000"/>
+                </a:solidFill>
+                <a:latin typeface="SB Sans Display"/>
+                <a:ea typeface="SB Sans Display"/>
+                <a:cs typeface="SB Sans Display"/>
+              </a:rPr>
+              <a:t> Full cramming</a:t>
+            </a:r>
+            <a:endParaRPr lang="en-US" sz="1400"/>
+          </a:p>
+        </p:txBody>
+      </p:sp>
+      <p:sp>
+        <p:nvSpPr>
+          <p:cNvPr id="50" name="TextBox 49"/>
+          <p:cNvSpPr txBox="1"/>
+          <p:nvPr/>
+        </p:nvSpPr>
+        <p:spPr>
+          <a:xfrm>
+            <a:off x="3554909" y="6358384"/>
+            <a:ext cx="2826841" cy="555129"/>
+          </a:xfrm>
+          <a:prstGeom prst="rect">
+            <a:avLst/>
+          </a:prstGeom>
+          <a:noFill/>
+        </p:spPr>
+        <p:txBody>
+          <a:bodyPr wrap="square" lIns="0" rIns="0" tIns="0" bIns="0" anchor="t">
+            <a:noAutofit/>
+          </a:bodyPr>
+          <a:lstStyle/>
+          <a:p>
+            <a:pPr algn="l">
+              <a:lnSpc>
+                <a:spcPts val="875"/>
+              </a:lnSpc>
+              <a:spcBef>
+                <a:spcPts val="0"/>
+              </a:spcBef>
+              <a:spcAft>
+                <a:spcPts val="0"/>
+              </a:spcAft>
+              <a:buNone/>
+            </a:pPr>
+            <a:r>
+              <a:rPr lang="en-US" sz="700">
+                <a:solidFill>
+                  <a:srgbClr val="000000"/>
+                </a:solidFill>
+                <a:latin typeface="SB Sans Text"/>
+                <a:ea typeface="SB Sans Text"/>
+                <a:cs typeface="SB Sans Text"/>
+              </a:rPr>
+              <a:t>Full cramming fixes the </a:t>
+            </a:r>
+            <a:r>
+              <a:rPr lang="en-US" sz="700">
+                <a:solidFill>
+                  <a:srgbClr val="26359A"/>
+                </a:solidFill>
+                <a:latin typeface="SB Sans Text"/>
+                <a:ea typeface="SB Sans Text"/>
+                <a:cs typeface="SB Sans Text"/>
+              </a:rPr>
+              <a:t>number of tokens</a:t>
+            </a:r>
+            <a:r>
+              <a:rPr lang="en-US" sz="700">
+                <a:solidFill>
+                  <a:srgbClr val="000000"/>
+                </a:solidFill>
+                <a:latin typeface="SB Sans Text"/>
+                <a:ea typeface="SB Sans Text"/>
+                <a:cs typeface="SB Sans Text"/>
+              </a:rPr>
+              <a:t> and optimises them jointly; progressive cramming fixes </a:t>
+            </a:r>
+            <a:r>
+              <a:rPr lang="en-US" sz="700">
+                <a:solidFill>
+                  <a:srgbClr val="26359A"/>
+                </a:solidFill>
+                <a:latin typeface="SB Sans Text"/>
+                <a:ea typeface="SB Sans Text"/>
+                <a:cs typeface="SB Sans Text"/>
+              </a:rPr>
+              <a:t>accuracy at 100%</a:t>
+            </a:r>
+            <a:r>
+              <a:rPr lang="en-US" sz="700">
+                <a:solidFill>
+                  <a:srgbClr val="000000"/>
+                </a:solidFill>
+                <a:latin typeface="SB Sans Text"/>
+                <a:ea typeface="SB Sans Text"/>
+                <a:cs typeface="SB Sans Text"/>
+              </a:rPr>
+              <a:t> and grows the text. Full cramming reaches more tokens, but its residual errors sit at </a:t>
+            </a:r>
+            <a:r>
+              <a:rPr lang="en-US" sz="700">
+                <a:solidFill>
+                  <a:srgbClr val="C0392B"/>
+                </a:solidFill>
+                <a:latin typeface="SB Sans Text"/>
+                <a:ea typeface="SB Sans Text"/>
+                <a:cs typeface="SB Sans Text"/>
+              </a:rPr>
+              <a:t>early positions</a:t>
+            </a:r>
+            <a:r>
+              <a:rPr lang="en-US" sz="700">
+                <a:solidFill>
+                  <a:srgbClr val="000000"/>
+                </a:solidFill>
+                <a:latin typeface="SB Sans Text"/>
+                <a:ea typeface="SB Sans Text"/>
+                <a:cs typeface="SB Sans Text"/>
+              </a:rPr>
+              <a:t>, and one early miss cascades through greedy generation:</a:t>
+            </a:r>
+            <a:endParaRPr lang="en-US" sz="700"/>
+          </a:p>
+        </p:txBody>
+      </p:sp>
+      <p:sp>
+        <p:nvSpPr>
+          <p:cNvPr id="51" name="TextBox 50"/>
+          <p:cNvSpPr txBox="1"/>
+          <p:nvPr/>
+        </p:nvSpPr>
+        <p:spPr>
+          <a:xfrm>
+            <a:off x="489645" y="9362926"/>
+            <a:ext cx="2155785" cy="213122"/>
+          </a:xfrm>
+          <a:prstGeom prst="rect">
+            <a:avLst/>
+          </a:prstGeom>
+          <a:noFill/>
+        </p:spPr>
+        <p:txBody>
+          <a:bodyPr wrap="square" lIns="0" rIns="0" tIns="0" bIns="0" anchor="t">
             <a:noAutofit/>
           </a:bodyPr>
           <a:lstStyle/>
@@ -8467,26 +9014,73 @@
               <a:buNone/>
             </a:pPr>
             <a:r>
-              <a:rPr lang="en-US" sz="700" cap="all" spc="28">
+              <a:rPr lang="en-US" sz="700" baseline="30000">
                 <a:solidFill>
-                  <a:srgbClr val="000000"/>
+                  <a:srgbClr val="FFFFFF"/>
                 </a:solidFill>
-                <a:latin typeface="SB Sans Display"/>
-                <a:ea typeface="SB Sans Display"/>
-                <a:cs typeface="SB Sans Display"/>
+                <a:latin typeface="SB Sans Display Light"/>
+                <a:ea typeface="SB Sans Display Light"/>
+                <a:cs typeface="SB Sans Display Light"/>
               </a:rPr>
-              <a:t>4</a:t>
-            </a:r>
-            <a:r>
-              <a:rPr lang="en-US" sz="700" cap="all" spc="28">
+              <a:t>1</a:t>
+            </a:r>
+            <a:r>
+              <a:rPr lang="en-US" sz="700">
                 <a:solidFill>
-                  <a:srgbClr val="000000"/>
+                  <a:srgbClr val="FFFFFF"/>
                 </a:solidFill>
-                <a:latin typeface="SB Sans Display"/>
-                <a:ea typeface="SB Sans Display"/>
-                <a:cs typeface="SB Sans Display"/>
+                <a:latin typeface="SB Sans Display Light"/>
+                <a:ea typeface="SB Sans Display Light"/>
+                <a:cs typeface="SB Sans Display Light"/>
               </a:rPr>
-              <a:t> Reconstruction ≠ understanding</a:t>
+              <a:t> AIRI, </a:t>
+            </a:r>
+            <a:r>
+              <a:rPr lang="en-US" sz="700" baseline="30000">
+                <a:solidFill>
+                  <a:srgbClr val="FFFFFF"/>
+                </a:solidFill>
+                <a:latin typeface="SB Sans Display Light"/>
+                <a:ea typeface="SB Sans Display Light"/>
+                <a:cs typeface="SB Sans Display Light"/>
+              </a:rPr>
+              <a:t>2</a:t>
+            </a:r>
+            <a:r>
+              <a:rPr lang="en-US" sz="700">
+                <a:solidFill>
+                  <a:srgbClr val="FFFFFF"/>
+                </a:solidFill>
+                <a:latin typeface="SB Sans Display Light"/>
+                <a:ea typeface="SB Sans Display Light"/>
+                <a:cs typeface="SB Sans Display Light"/>
+              </a:rPr>
+              <a:t> HSE University,</a:t>
+            </a:r>
+            <a:br>
+              <a:rPr lang="en-US" sz="700"/>
+            </a:br>
+            <a:r>
+              <a:rPr lang="en-US" sz="700" baseline="30000">
+                <a:solidFill>
+                  <a:srgbClr val="FFFFFF"/>
+                </a:solidFill>
+                <a:latin typeface="SB Sans Display Light"/>
+                <a:ea typeface="SB Sans Display Light"/>
+                <a:cs typeface="SB Sans Display Light"/>
+              </a:rPr>
+              <a:t>3</a:t>
+            </a:r>
+            <a:r>
+              <a:rPr lang="en-US" sz="700">
+                <a:solidFill>
+                  <a:srgbClr val="FFFFFF"/>
+                </a:solidFill>
+                <a:latin typeface="SB Sans Display Light"/>
+                <a:ea typeface="SB Sans Display Light"/>
+                <a:cs typeface="SB Sans Display Light"/>
+              </a:rPr>
+              <a:t> Innopolis University</a:t>
             </a:r>
             <a:endParaRPr lang="en-US" sz="700"/>
           </a:p>
@@ -8494,178 +9088,14 @@
       </p:sp>
       <p:sp>
         <p:nvSpPr>
-          <p:cNvPr id="46" name="TextBox 45"/>
+          <p:cNvPr id="52" name="TextBox 51"/>
           <p:cNvSpPr txBox="1"/>
           <p:nvPr/>
         </p:nvSpPr>
         <p:spPr>
           <a:xfrm>
-            <a:off x="3554760" y="2049363"/>
-            <a:ext cx="2879063" cy="222052"/>
-          </a:xfrm>
-          <a:prstGeom prst="rect">
-            <a:avLst/>
-          </a:prstGeom>
-          <a:noFill/>
-        </p:spPr>
-        <p:txBody>
-          <a:bodyPr wrap="square" lIns="0" rIns="0" tIns="0" bIns="0" anchor="t">
-            <a:noAutofit/>
-          </a:bodyPr>
-          <a:lstStyle/>
-          <a:p>
-            <a:pPr algn="l">
-              <a:lnSpc>
-                <a:spcPts val="875"/>
-              </a:lnSpc>
-              <a:spcBef>
-                <a:spcPts val="0"/>
-              </a:spcBef>
-              <a:spcAft>
-                <a:spcPts val="0"/>
-              </a:spcAft>
-              <a:buNone/>
-            </a:pPr>
-            <a:r>
-              <a:rPr lang="en-US" sz="700">
-                <a:solidFill>
-                  <a:srgbClr val="1B1F2A"/>
-                </a:solidFill>
-                <a:latin typeface="SB Sans Display Light"/>
-                <a:ea typeface="SB Sans Display Light"/>
-                <a:cs typeface="SB Sans Display Light"/>
-              </a:rPr>
-              <a:t>Prepending a crammed embedding </a:t>
-            </a:r>
-            <a:r>
-              <a:rPr lang="en-US" sz="700">
-                <a:solidFill>
-                  <a:srgbClr val="C0392B"/>
-                </a:solidFill>
-                <a:latin typeface="SB Sans Display"/>
-                <a:ea typeface="SB Sans Display"/>
-                <a:cs typeface="SB Sans Display"/>
-              </a:rPr>
-              <a:t>drops</a:t>
-            </a:r>
-            <a:r>
-              <a:rPr lang="en-US" sz="700">
-                <a:solidFill>
-                  <a:srgbClr val="1B1F2A"/>
-                </a:solidFill>
-                <a:latin typeface="SB Sans Display Light"/>
-                <a:ea typeface="SB Sans Display Light"/>
-                <a:cs typeface="SB Sans Display Light"/>
-              </a:rPr>
-              <a:t> benchmark accuracy even with the original prefix in context:</a:t>
-            </a:r>
-            <a:endParaRPr lang="en-US" sz="700"/>
-          </a:p>
-        </p:txBody>
-      </p:sp>
-      <p:sp>
-        <p:nvSpPr>
-          <p:cNvPr id="47" name="TextBox 46"/>
-          <p:cNvSpPr txBox="1"/>
-          <p:nvPr/>
-        </p:nvSpPr>
-        <p:spPr>
-          <a:xfrm>
-            <a:off x="3554760" y="3034308"/>
-            <a:ext cx="2879063" cy="222052"/>
-          </a:xfrm>
-          <a:prstGeom prst="rect">
-            <a:avLst/>
-          </a:prstGeom>
-          <a:noFill/>
-        </p:spPr>
-        <p:txBody>
-          <a:bodyPr wrap="square" lIns="0" rIns="0" tIns="0" bIns="0" anchor="t">
-            <a:noAutofit/>
-          </a:bodyPr>
-          <a:lstStyle/>
-          <a:p>
-            <a:pPr algn="l">
-              <a:lnSpc>
-                <a:spcPts val="875"/>
-              </a:lnSpc>
-              <a:spcBef>
-                <a:spcPts val="0"/>
-              </a:spcBef>
-              <a:spcAft>
-                <a:spcPts val="0"/>
-              </a:spcAft>
-              <a:buNone/>
-            </a:pPr>
-            <a:r>
-              <a:rPr lang="en-US" sz="700">
-                <a:solidFill>
-                  <a:srgbClr val="1B1F2A"/>
-                </a:solidFill>
-                <a:latin typeface="SB Sans Display Light"/>
-                <a:ea typeface="SB Sans Display Light"/>
-                <a:cs typeface="SB Sans Display Light"/>
-              </a:rPr>
-              <a:t>On </a:t>
-            </a:r>
-            <a:r>
-              <a:rPr lang="en-US" sz="700" b="1">
-                <a:solidFill>
-                  <a:srgbClr val="1B1F2A"/>
-                </a:solidFill>
-                <a:latin typeface="SB Sans Display"/>
-                <a:ea typeface="SB Sans Display"/>
-                <a:cs typeface="SB Sans Display"/>
-              </a:rPr>
-              <a:t>generative 5-shot MMLU</a:t>
-            </a:r>
-            <a:r>
-              <a:rPr lang="en-US" sz="700">
-                <a:solidFill>
-                  <a:srgbClr val="1B1F2A"/>
-                </a:solidFill>
-                <a:latin typeface="SB Sans Display Light"/>
-                <a:ea typeface="SB Sans Display Light"/>
-                <a:cs typeface="SB Sans Display Light"/>
-              </a:rPr>
-              <a:t> accuracy falls to </a:t>
-            </a:r>
-            <a:r>
-              <a:rPr lang="en-US" sz="700">
-                <a:solidFill>
-                  <a:srgbClr val="C0392B"/>
-                </a:solidFill>
-                <a:latin typeface="SB Sans Display"/>
-                <a:ea typeface="SB Sans Display"/>
-                <a:cs typeface="SB Sans Display"/>
-              </a:rPr>
-              <a:t>≈0%</a:t>
-            </a:r>
-            <a:r>
-              <a:rPr lang="en-US" sz="700">
-                <a:solidFill>
-                  <a:srgbClr val="1B1F2A"/>
-                </a:solidFill>
-                <a:latin typeface="SB Sans Display Light"/>
-                <a:ea typeface="SB Sans Display Light"/>
-                <a:cs typeface="SB Sans Display Light"/>
-              </a:rPr>
-              <a:t> with the optimised embedding, while a random-embedding control stays at the baseline.</a:t>
-            </a:r>
-            <a:endParaRPr lang="en-US" sz="700"/>
-          </a:p>
-        </p:txBody>
-      </p:sp>
-      <p:sp>
-        <p:nvSpPr>
-          <p:cNvPr id="48" name="TextBox 47"/>
-          <p:cNvSpPr txBox="1"/>
-          <p:nvPr/>
-        </p:nvSpPr>
-        <p:spPr>
-          <a:xfrm>
-            <a:off x="3554760" y="3517702"/>
-            <a:ext cx="2879063" cy="106561"/>
+            <a:off x="489645" y="9611916"/>
+            <a:ext cx="2155785" cy="106561"/>
           </a:xfrm>
           <a:prstGeom prst="rect">
             <a:avLst/>
@@ -8691,627 +9121,6 @@
               <a:buNone/>
             </a:pPr>
             <a:r>
-              <a:rPr lang="en-US" sz="700" cap="all" spc="28">
-                <a:solidFill>
-                  <a:srgbClr val="000000"/>
-                </a:solidFill>
-                <a:latin typeface="SB Sans Display"/>
-                <a:ea typeface="SB Sans Display"/>
-                <a:cs typeface="SB Sans Display"/>
-              </a:rPr>
-              <a:t>5</a:t>
-            </a:r>
-            <a:r>
-              <a:rPr lang="en-US" sz="700" cap="all" spc="28">
-                <a:solidFill>
-                  <a:srgbClr val="000000"/>
-                </a:solidFill>
-                <a:latin typeface="SB Sans Display"/>
-                <a:ea typeface="SB Sans Display"/>
-                <a:cs typeface="SB Sans Display"/>
-              </a:rPr>
-              <a:t> Attention knockout</a:t>
-            </a:r>
-            <a:endParaRPr lang="en-US" sz="700"/>
-          </a:p>
-        </p:txBody>
-      </p:sp>
-      <p:sp>
-        <p:nvSpPr>
-          <p:cNvPr id="49" name="TextBox 48"/>
-          <p:cNvSpPr txBox="1"/>
-          <p:nvPr/>
-        </p:nvSpPr>
-        <p:spPr>
-          <a:xfrm>
-            <a:off x="3554760" y="4621113"/>
-            <a:ext cx="2879063" cy="333077"/>
-          </a:xfrm>
-          <a:prstGeom prst="rect">
-            <a:avLst/>
-          </a:prstGeom>
-          <a:noFill/>
-        </p:spPr>
-        <p:txBody>
-          <a:bodyPr wrap="square" lIns="0" rIns="0" tIns="0" bIns="0" anchor="t">
-            <a:noAutofit/>
-          </a:bodyPr>
-          <a:lstStyle/>
-          <a:p>
-            <a:pPr algn="l">
-              <a:lnSpc>
-                <a:spcPts val="875"/>
-              </a:lnSpc>
-              <a:spcBef>
-                <a:spcPts val="0"/>
-              </a:spcBef>
-              <a:spcAft>
-                <a:spcPts val="0"/>
-              </a:spcAft>
-              <a:buNone/>
-            </a:pPr>
-            <a:r>
-              <a:rPr lang="en-US" sz="700" b="1">
-                <a:solidFill>
-                  <a:srgbClr val="5A6275"/>
-                </a:solidFill>
-                <a:latin typeface="SB Sans Display"/>
-                <a:ea typeface="SB Sans Display"/>
-                <a:cs typeface="SB Sans Display"/>
-              </a:rPr>
-              <a:t>Llama-3.1-8B.</a:t>
-            </a:r>
-            <a:r>
-              <a:rPr lang="en-US" sz="700">
-                <a:solidFill>
-                  <a:srgbClr val="5A6275"/>
-                </a:solidFill>
-                <a:latin typeface="SB Sans Display Light"/>
-                <a:ea typeface="SB Sans Display Light"/>
-                <a:cs typeface="SB Sans Display Light"/>
-              </a:rPr>
-              <a:t> Forward knockout (masking early layers first) restores downstream accuracy, while reverse knockout fails until the early layers are masked too.</a:t>
-            </a:r>
-            <a:endParaRPr lang="en-US" sz="700"/>
-          </a:p>
-        </p:txBody>
-      </p:sp>
-      <p:sp>
-        <p:nvSpPr>
-          <p:cNvPr id="50" name="TextBox 49"/>
-          <p:cNvSpPr txBox="1"/>
-          <p:nvPr/>
-        </p:nvSpPr>
-        <p:spPr>
-          <a:xfrm>
-            <a:off x="3554760" y="5008066"/>
-            <a:ext cx="2879063" cy="333077"/>
-          </a:xfrm>
-          <a:prstGeom prst="rect">
-            <a:avLst/>
-          </a:prstGeom>
-          <a:noFill/>
-        </p:spPr>
-        <p:txBody>
-          <a:bodyPr wrap="square" lIns="0" rIns="0" tIns="0" bIns="0" anchor="t">
-            <a:noAutofit/>
-          </a:bodyPr>
-          <a:lstStyle/>
-          <a:p>
-            <a:pPr algn="l">
-              <a:lnSpc>
-                <a:spcPts val="875"/>
-              </a:lnSpc>
-              <a:spcBef>
-                <a:spcPts val="0"/>
-              </a:spcBef>
-              <a:spcAft>
-                <a:spcPts val="0"/>
-              </a:spcAft>
-              <a:buNone/>
-            </a:pPr>
-            <a:r>
-              <a:rPr lang="en-US" sz="700">
-                <a:solidFill>
-                  <a:srgbClr val="26359A"/>
-                </a:solidFill>
-                <a:latin typeface="SB Sans Display"/>
-                <a:ea typeface="SB Sans Display"/>
-                <a:cs typeface="SB Sans Display"/>
-              </a:rPr>
-              <a:t>Early layers</a:t>
-            </a:r>
-            <a:r>
-              <a:rPr lang="en-US" sz="700">
-                <a:solidFill>
-                  <a:srgbClr val="1B1F2A"/>
-                </a:solidFill>
-                <a:latin typeface="SB Sans Display Light"/>
-                <a:ea typeface="SB Sans Display Light"/>
-                <a:cs typeface="SB Sans Display Light"/>
-              </a:rPr>
-              <a:t> drive both the reconstruction and the capability collapse; the 20–60% late-layer attention mass is a symptom. The pattern holds for Llama-3.1-8B, Pythia-1.4B and SmolLM2-1.7B.</a:t>
-            </a:r>
-            <a:endParaRPr lang="en-US" sz="700"/>
-          </a:p>
-        </p:txBody>
-      </p:sp>
-      <p:sp>
-        <p:nvSpPr>
-          <p:cNvPr id="51" name="TextBox 50"/>
-          <p:cNvSpPr txBox="1"/>
-          <p:nvPr/>
-        </p:nvSpPr>
-        <p:spPr>
-          <a:xfrm>
-            <a:off x="3554760" y="5602486"/>
-            <a:ext cx="2879063" cy="106561"/>
-          </a:xfrm>
-          <a:prstGeom prst="rect">
-            <a:avLst/>
-          </a:prstGeom>
-          <a:noFill/>
-        </p:spPr>
-        <p:txBody>
-          <a:bodyPr wrap="none" lIns="0" rIns="0" tIns="0" bIns="0" anchor="t">
-            <a:noAutofit/>
-          </a:bodyPr>
-          <a:lstStyle/>
-          <a:p>
-            <a:pPr algn="l">
-              <a:lnSpc>
-                <a:spcPts val="840"/>
-              </a:lnSpc>
-              <a:spcBef>
-                <a:spcPts val="0"/>
-              </a:spcBef>
-              <a:spcAft>
-                <a:spcPts val="0"/>
-              </a:spcAft>
-              <a:buNone/>
-            </a:pPr>
-            <a:r>
-              <a:rPr lang="en-US" sz="700" cap="all" spc="28">
-                <a:solidFill>
-                  <a:srgbClr val="000000"/>
-                </a:solidFill>
-                <a:latin typeface="SB Sans Display"/>
-                <a:ea typeface="SB Sans Display"/>
-                <a:cs typeface="SB Sans Display"/>
-              </a:rPr>
-              <a:t>6</a:t>
-            </a:r>
-            <a:r>
-              <a:rPr lang="en-US" sz="700" cap="all" spc="28">
-                <a:solidFill>
-                  <a:srgbClr val="000000"/>
-                </a:solidFill>
-                <a:latin typeface="SB Sans Display"/>
-                <a:ea typeface="SB Sans Display"/>
-                <a:cs typeface="SB Sans Display"/>
-              </a:rPr>
-              <a:t> Why not full cramming?</a:t>
-            </a:r>
-            <a:endParaRPr lang="en-US" sz="700"/>
-          </a:p>
-        </p:txBody>
-      </p:sp>
-      <p:sp>
-        <p:nvSpPr>
-          <p:cNvPr id="52" name="TextBox 51"/>
-          <p:cNvSpPr txBox="1"/>
-          <p:nvPr/>
-        </p:nvSpPr>
-        <p:spPr>
-          <a:xfrm>
-            <a:off x="3554760" y="5762923"/>
-            <a:ext cx="2879063" cy="444103"/>
-          </a:xfrm>
-          <a:prstGeom prst="rect">
-            <a:avLst/>
-          </a:prstGeom>
-          <a:noFill/>
-        </p:spPr>
-        <p:txBody>
-          <a:bodyPr wrap="square" lIns="0" rIns="0" tIns="0" bIns="0" anchor="t">
-            <a:noAutofit/>
-          </a:bodyPr>
-          <a:lstStyle/>
-          <a:p>
-            <a:pPr algn="l">
-              <a:lnSpc>
-                <a:spcPts val="875"/>
-              </a:lnSpc>
-              <a:spcBef>
-                <a:spcPts val="0"/>
-              </a:spcBef>
-              <a:spcAft>
-                <a:spcPts val="0"/>
-              </a:spcAft>
-              <a:buNone/>
-            </a:pPr>
-            <a:r>
-              <a:rPr lang="en-US" sz="700">
-                <a:solidFill>
-                  <a:srgbClr val="1B1F2A"/>
-                </a:solidFill>
-                <a:latin typeface="SB Sans Display Light"/>
-                <a:ea typeface="SB Sans Display Light"/>
-                <a:cs typeface="SB Sans Display Light"/>
-              </a:rPr>
-              <a:t>Full cramming fixes the </a:t>
-            </a:r>
-            <a:r>
-              <a:rPr lang="en-US" sz="700">
-                <a:solidFill>
-                  <a:srgbClr val="26359A"/>
-                </a:solidFill>
-                <a:latin typeface="SB Sans Display"/>
-                <a:ea typeface="SB Sans Display"/>
-                <a:cs typeface="SB Sans Display"/>
-              </a:rPr>
-              <a:t>number of tokens</a:t>
-            </a:r>
-            <a:r>
-              <a:rPr lang="en-US" sz="700">
-                <a:solidFill>
-                  <a:srgbClr val="1B1F2A"/>
-                </a:solidFill>
-                <a:latin typeface="SB Sans Display Light"/>
-                <a:ea typeface="SB Sans Display Light"/>
-                <a:cs typeface="SB Sans Display Light"/>
-              </a:rPr>
-              <a:t> and optimises them jointly; progressive cramming fixes </a:t>
-            </a:r>
-            <a:r>
-              <a:rPr lang="en-US" sz="700">
-                <a:solidFill>
-                  <a:srgbClr val="26359A"/>
-                </a:solidFill>
-                <a:latin typeface="SB Sans Display"/>
-                <a:ea typeface="SB Sans Display"/>
-                <a:cs typeface="SB Sans Display"/>
-              </a:rPr>
-              <a:t>accuracy at 100%</a:t>
-            </a:r>
-            <a:r>
-              <a:rPr lang="en-US" sz="700">
-                <a:solidFill>
-                  <a:srgbClr val="1B1F2A"/>
-                </a:solidFill>
-                <a:latin typeface="SB Sans Display Light"/>
-                <a:ea typeface="SB Sans Display Light"/>
-                <a:cs typeface="SB Sans Display Light"/>
-              </a:rPr>
-              <a:t> and grows the text. Full cramming reaches more tokens, but its residual errors sit at </a:t>
-            </a:r>
-            <a:r>
-              <a:rPr lang="en-US" sz="700">
-                <a:solidFill>
-                  <a:srgbClr val="C0392B"/>
-                </a:solidFill>
-                <a:latin typeface="SB Sans Display"/>
-                <a:ea typeface="SB Sans Display"/>
-                <a:cs typeface="SB Sans Display"/>
-              </a:rPr>
-              <a:t>early positions</a:t>
-            </a:r>
-            <a:r>
-              <a:rPr lang="en-US" sz="700">
-                <a:solidFill>
-                  <a:srgbClr val="1B1F2A"/>
-                </a:solidFill>
-                <a:latin typeface="SB Sans Display Light"/>
-                <a:ea typeface="SB Sans Display Light"/>
-                <a:cs typeface="SB Sans Display Light"/>
-              </a:rPr>
-              <a:t>, and one early miss cascades through greedy generation:</a:t>
-            </a:r>
-            <a:endParaRPr lang="en-US" sz="700"/>
-          </a:p>
-        </p:txBody>
-      </p:sp>
-      <p:sp>
-        <p:nvSpPr>
-          <p:cNvPr id="53" name="TextBox 52"/>
-          <p:cNvSpPr txBox="1"/>
-          <p:nvPr/>
-        </p:nvSpPr>
-        <p:spPr>
-          <a:xfrm>
-            <a:off x="3554760" y="8264872"/>
-            <a:ext cx="2879063" cy="106561"/>
-          </a:xfrm>
-          <a:prstGeom prst="rect">
-            <a:avLst/>
-          </a:prstGeom>
-          <a:noFill/>
-        </p:spPr>
-        <p:txBody>
-          <a:bodyPr wrap="none" lIns="0" rIns="0" tIns="0" bIns="0" anchor="t">
-            <a:noAutofit/>
-          </a:bodyPr>
-          <a:lstStyle/>
-          <a:p>
-            <a:pPr algn="l">
-              <a:lnSpc>
-                <a:spcPts val="840"/>
-              </a:lnSpc>
-              <a:spcBef>
-                <a:spcPts val="0"/>
-              </a:spcBef>
-              <a:spcAft>
-                <a:spcPts val="0"/>
-              </a:spcAft>
-              <a:buNone/>
-            </a:pPr>
-            <a:r>
-              <a:rPr lang="en-US" sz="700" cap="all" spc="28">
-                <a:solidFill>
-                  <a:srgbClr val="000000"/>
-                </a:solidFill>
-                <a:latin typeface="SB Sans Display"/>
-                <a:ea typeface="SB Sans Display"/>
-                <a:cs typeface="SB Sans Display"/>
-              </a:rPr>
-              <a:t>7</a:t>
-            </a:r>
-            <a:r>
-              <a:rPr lang="en-US" sz="700" cap="all" spc="28">
-                <a:solidFill>
-                  <a:srgbClr val="000000"/>
-                </a:solidFill>
-                <a:latin typeface="SB Sans Display"/>
-                <a:ea typeface="SB Sans Display"/>
-                <a:cs typeface="SB Sans Display"/>
-              </a:rPr>
-              <a:t> Takeaways</a:t>
-            </a:r>
-            <a:endParaRPr lang="en-US" sz="700"/>
-          </a:p>
-        </p:txBody>
-      </p:sp>
-      <p:sp>
-        <p:nvSpPr>
-          <p:cNvPr id="54" name="TextBox 53"/>
-          <p:cNvSpPr txBox="1"/>
-          <p:nvPr/>
-        </p:nvSpPr>
-        <p:spPr>
-          <a:xfrm>
-            <a:off x="3554760" y="8425309"/>
-            <a:ext cx="2879063" cy="465683"/>
-          </a:xfrm>
-          <a:prstGeom prst="rect">
-            <a:avLst/>
-          </a:prstGeom>
-          <a:noFill/>
-        </p:spPr>
-        <p:txBody>
-          <a:bodyPr wrap="square" lIns="0" rIns="0" tIns="0" bIns="0" anchor="t">
-            <a:noAutofit/>
-          </a:bodyPr>
-          <a:lstStyle/>
-          <a:p>
-            <a:pPr algn="l" marL="115200" indent="-115200">
-              <a:lnSpc>
-                <a:spcPts val="875"/>
-              </a:lnSpc>
-              <a:spcBef>
-                <a:spcPts val="0"/>
-              </a:spcBef>
-              <a:spcAft>
-                <a:spcPts val="0"/>
-              </a:spcAft>
-              <a:buFont typeface="Arial"/>
-              <a:buChar char="•"/>
-            </a:pPr>
-            <a:r>
-              <a:rPr lang="en-US" sz="700" b="1">
-                <a:solidFill>
-                  <a:srgbClr val="1B1F2A"/>
-                </a:solidFill>
-                <a:latin typeface="SB Sans Display"/>
-                <a:ea typeface="SB Sans Display"/>
-                <a:cs typeface="SB Sans Display"/>
-              </a:rPr>
-              <a:t>Brittle steering.</a:t>
-            </a:r>
-            <a:r>
-              <a:rPr lang="en-US" sz="700">
-                <a:solidFill>
-                  <a:srgbClr val="1B1F2A"/>
-                </a:solidFill>
-                <a:latin typeface="SB Sans Display Light"/>
-                <a:ea typeface="SB Sans Display Light"/>
-                <a:cs typeface="SB Sans Display Light"/>
-              </a:rPr>
-              <a:t> Perfect reconstruction stores nothing the model can use: benchmarks drop and generative MMLU collapses to ≈0%.</a:t>
-            </a:r>
-            <a:endParaRPr lang="en-US" sz="700"/>
-          </a:p>
-          <a:p>
-            <a:pPr algn="l" marL="115200" indent="-115200">
-              <a:lnSpc>
-                <a:spcPts val="875"/>
-              </a:lnSpc>
-              <a:spcBef>
-                <a:spcPts val="170"/>
-              </a:spcBef>
-              <a:spcAft>
-                <a:spcPts val="0"/>
-              </a:spcAft>
-              <a:buFont typeface="Arial"/>
-              <a:buChar char="•"/>
-            </a:pPr>
-            <a:r>
-              <a:rPr lang="en-US" sz="700" b="1">
-                <a:solidFill>
-                  <a:srgbClr val="1B1F2A"/>
-                </a:solidFill>
-                <a:latin typeface="SB Sans Display"/>
-                <a:ea typeface="SB Sans Display"/>
-                <a:cs typeface="SB Sans Display"/>
-              </a:rPr>
-              <a:t>Early layers.</a:t>
-            </a:r>
-            <a:r>
-              <a:rPr lang="en-US" sz="700">
-                <a:solidFill>
-                  <a:srgbClr val="1B1F2A"/>
-                </a:solidFill>
-                <a:latin typeface="SB Sans Display Light"/>
-                <a:ea typeface="SB Sans Display Light"/>
-                <a:cs typeface="SB Sans Display Light"/>
-              </a:rPr>
-              <a:t> The embedding's causal influence concentrates in the first layers across all model families.</a:t>
-            </a:r>
-            <a:endParaRPr lang="en-US" sz="700"/>
-          </a:p>
-        </p:txBody>
-      </p:sp>
-      <p:sp>
-        <p:nvSpPr>
-          <p:cNvPr id="55" name="TextBox 54"/>
-          <p:cNvSpPr txBox="1"/>
-          <p:nvPr/>
-        </p:nvSpPr>
-        <p:spPr>
-          <a:xfrm>
-            <a:off x="494854" y="9319171"/>
-            <a:ext cx="2676340" cy="213122"/>
-          </a:xfrm>
-          <a:prstGeom prst="rect">
-            <a:avLst/>
-          </a:prstGeom>
-          <a:noFill/>
-        </p:spPr>
-        <p:txBody>
-          <a:bodyPr wrap="square" lIns="0" rIns="0" tIns="0" bIns="0" anchor="t">
-            <a:noAutofit/>
-          </a:bodyPr>
-          <a:lstStyle/>
-          <a:p>
-            <a:pPr algn="l">
-              <a:lnSpc>
-                <a:spcPts val="840"/>
-              </a:lnSpc>
-              <a:spcBef>
-                <a:spcPts val="0"/>
-              </a:spcBef>
-              <a:spcAft>
-                <a:spcPts val="0"/>
-              </a:spcAft>
-              <a:buNone/>
-            </a:pPr>
-            <a:r>
-              <a:rPr lang="en-US" sz="700" baseline="30000">
-                <a:solidFill>
-                  <a:srgbClr val="FFFFFF"/>
-                </a:solidFill>
-                <a:latin typeface="SB Sans Display Light"/>
-                <a:ea typeface="SB Sans Display Light"/>
-                <a:cs typeface="SB Sans Display Light"/>
-              </a:rPr>
-              <a:t>1</a:t>
-            </a:r>
-            <a:r>
-              <a:rPr lang="en-US" sz="700">
-                <a:solidFill>
-                  <a:srgbClr val="FFFFFF"/>
-                </a:solidFill>
-                <a:latin typeface="SB Sans Display Light"/>
-                <a:ea typeface="SB Sans Display Light"/>
-                <a:cs typeface="SB Sans Display Light"/>
-              </a:rPr>
-              <a:t> FusionBrain Lab, AIRI, </a:t>
-            </a:r>
-            <a:r>
-              <a:rPr lang="en-US" sz="700" baseline="30000">
-                <a:solidFill>
-                  <a:srgbClr val="FFFFFF"/>
-                </a:solidFill>
-                <a:latin typeface="SB Sans Display Light"/>
-                <a:ea typeface="SB Sans Display Light"/>
-                <a:cs typeface="SB Sans Display Light"/>
-              </a:rPr>
-              <a:t>2</a:t>
-            </a:r>
-            <a:r>
-              <a:rPr lang="en-US" sz="700">
-                <a:solidFill>
-                  <a:srgbClr val="FFFFFF"/>
-                </a:solidFill>
-                <a:latin typeface="SB Sans Display Light"/>
-                <a:ea typeface="SB Sans Display Light"/>
-                <a:cs typeface="SB Sans Display Light"/>
-              </a:rPr>
-              <a:t> HSE University, Moscow,</a:t>
-            </a:r>
-            <a:br>
-              <a:rPr lang="en-US" sz="700"/>
-            </a:br>
-            <a:r>
-              <a:rPr lang="en-US" sz="700" baseline="30000">
-                <a:solidFill>
-                  <a:srgbClr val="FFFFFF"/>
-                </a:solidFill>
-                <a:latin typeface="SB Sans Display Light"/>
-                <a:ea typeface="SB Sans Display Light"/>
-                <a:cs typeface="SB Sans Display Light"/>
-              </a:rPr>
-              <a:t>3</a:t>
-            </a:r>
-            <a:r>
-              <a:rPr lang="en-US" sz="700">
-                <a:solidFill>
-                  <a:srgbClr val="FFFFFF"/>
-                </a:solidFill>
-                <a:latin typeface="SB Sans Display Light"/>
-                <a:ea typeface="SB Sans Display Light"/>
-                <a:cs typeface="SB Sans Display Light"/>
-              </a:rPr>
-              <a:t> Innopolis University</a:t>
-            </a:r>
-            <a:endParaRPr lang="en-US" sz="700"/>
-          </a:p>
-        </p:txBody>
-      </p:sp>
-      <p:sp>
-        <p:nvSpPr>
-          <p:cNvPr id="56" name="TextBox 55"/>
-          <p:cNvSpPr txBox="1"/>
-          <p:nvPr/>
-        </p:nvSpPr>
-        <p:spPr>
-          <a:xfrm>
-            <a:off x="489645" y="9653736"/>
-            <a:ext cx="2676340" cy="106561"/>
-          </a:xfrm>
-          <a:prstGeom prst="rect">
-            <a:avLst/>
-          </a:prstGeom>
-          <a:noFill/>
-        </p:spPr>
-        <p:txBody>
-          <a:bodyPr wrap="none" lIns="0" rIns="0" tIns="0" bIns="0" anchor="t">
-            <a:noAutofit/>
-          </a:bodyPr>
-          <a:lstStyle/>
-          <a:p>
-            <a:pPr algn="l">
-              <a:lnSpc>
-                <a:spcPts val="840"/>
-              </a:lnSpc>
-              <a:spcBef>
-                <a:spcPts val="0"/>
-              </a:spcBef>
-              <a:spcAft>
-                <a:spcPts val="0"/>
-              </a:spcAft>
-              <a:buNone/>
-            </a:pPr>
-            <a:r>
               <a:rPr lang="en-US" sz="700">
                 <a:solidFill>
                   <a:srgbClr val="FFFFFF"/>
@@ -9330,14 +9139,14 @@
         <mc:Choice xmlns:a14="http://schemas.microsoft.com/office/drawing/2010/main" Requires="a14">
           <p:sp>
             <p:nvSpPr>
-              <p:cNvPr id="57" name="TextBox 56"/>
+              <p:cNvPr id="53" name="TextBox 52"/>
               <p:cNvSpPr txBox="1"/>
               <p:nvPr/>
             </p:nvSpPr>
             <p:spPr>
               <a:xfrm>
-                <a:off x="518117" y="5243810"/>
-                <a:ext cx="2732987" cy="113854"/>
+                <a:off x="548134" y="6050756"/>
+                <a:ext cx="2682925" cy="126653"/>
               </a:xfrm>
               <a:prstGeom prst="rect">
                 <a:avLst/>
@@ -9367,7 +9176,7 @@
                             </ns0:rPr>
                             <a:rPr lang="en-US" sz="700" b="1">
                               <a:solidFill>
-                                <a:srgbClr val="1B1F2A"/>
+                                <a:srgbClr val="000000"/>
                               </a:solidFill>
                               <a:latin typeface="Cambria Math" panose="02040503050406030204" pitchFamily="18" charset="0"/>
                               <a:cs typeface="Cambria Math" panose="02040503050406030204" pitchFamily="18" charset="0"/>
@@ -9382,7 +9191,7 @@
                         </ns0:rPr>
                         <a:rPr lang="en-US" sz="700">
                           <a:solidFill>
-                            <a:srgbClr val="1B1F2A"/>
+                            <a:srgbClr val="000000"/>
                           </a:solidFill>
                           <a:latin typeface="Cambria Math" panose="02040503050406030204" pitchFamily="18" charset="0"/>
                           <a:cs typeface="Cambria Math" panose="02040503050406030204" pitchFamily="18" charset="0"/>
@@ -9395,7 +9204,7 @@
                         </ns0:rPr>
                         <a:rPr lang="en-US" sz="700" i="1">
                           <a:solidFill>
-                            <a:srgbClr val="1B1F2A"/>
+                            <a:srgbClr val="000000"/>
                           </a:solidFill>
                           <a:latin typeface="Cambria Math" panose="02040503050406030204" pitchFamily="18" charset="0"/>
                           <a:cs typeface="Cambria Math" panose="02040503050406030204" pitchFamily="18" charset="0"/>
@@ -9410,7 +9219,7 @@
                             </ns0:rPr>
                             <a:rPr lang="en-US" sz="700" b="1">
                               <a:solidFill>
-                                <a:srgbClr val="1B1F2A"/>
+                                <a:srgbClr val="000000"/>
                               </a:solidFill>
                               <a:latin typeface="Cambria Math" panose="02040503050406030204" pitchFamily="18" charset="0"/>
                               <a:cs typeface="Cambria Math" panose="02040503050406030204" pitchFamily="18" charset="0"/>
@@ -9425,7 +9234,7 @@
                         </ns0:rPr>
                         <a:rPr lang="en-US" sz="700">
                           <a:solidFill>
-                            <a:srgbClr val="1B1F2A"/>
+                            <a:srgbClr val="000000"/>
                           </a:solidFill>
                           <a:latin typeface="Cambria Math" panose="02040503050406030204" pitchFamily="18" charset="0"/>
                           <a:cs typeface="Cambria Math" panose="02040503050406030204" pitchFamily="18" charset="0"/>
@@ -9440,7 +9249,7 @@
                             </ns0:rPr>
                             <a:rPr lang="en-US" sz="700" b="1">
                               <a:solidFill>
-                                <a:srgbClr val="1B1F2A"/>
+                                <a:srgbClr val="000000"/>
                               </a:solidFill>
                               <a:latin typeface="Cambria Math" panose="02040503050406030204" pitchFamily="18" charset="0"/>
                               <a:cs typeface="Cambria Math" panose="02040503050406030204" pitchFamily="18" charset="0"/>
@@ -9455,7 +9264,7 @@
                         </ns0:rPr>
                         <a:rPr lang="en-US" sz="700">
                           <a:solidFill>
-                            <a:srgbClr val="1B1F2A"/>
+                            <a:srgbClr val="000000"/>
                           </a:solidFill>
                           <a:latin typeface="Cambria Math" panose="02040503050406030204" pitchFamily="18" charset="0"/>
                           <a:cs typeface="Cambria Math" panose="02040503050406030204" pitchFamily="18" charset="0"/>
@@ -9473,7 +9282,7 @@
                                 </ns0:rPr>
                                 <a:rPr lang="en-US" sz="700" i="1">
                                   <a:solidFill>
-                                    <a:srgbClr val="1B1F2A"/>
+                                    <a:srgbClr val="000000"/>
                                   </a:solidFill>
                                   <a:latin typeface="Cambria Math" panose="02040503050406030204" pitchFamily="18" charset="0"/>
                                   <a:cs typeface="Cambria Math" panose="02040503050406030204" pitchFamily="18" charset="0"/>
@@ -9490,7 +9299,7 @@
                             </ns0:rPr>
                             <a:rPr lang="en-US" sz="700" i="1">
                               <a:solidFill>
-                                <a:srgbClr val="1B1F2A"/>
+                                <a:srgbClr val="000000"/>
                               </a:solidFill>
                               <a:latin typeface="Cambria Math" panose="02040503050406030204" pitchFamily="18" charset="0"/>
                               <a:cs typeface="Cambria Math" panose="02040503050406030204" pitchFamily="18" charset="0"/>
@@ -9505,7 +9314,7 @@
                         </ns0:rPr>
                         <a:rPr lang="en-US" sz="700">
                           <a:solidFill>
-                            <a:srgbClr val="1B1F2A"/>
+                            <a:srgbClr val="000000"/>
                           </a:solidFill>
                           <a:latin typeface="Cambria Math" panose="02040503050406030204" pitchFamily="18" charset="0"/>
                           <a:cs typeface="Cambria Math" panose="02040503050406030204" pitchFamily="18" charset="0"/>
@@ -9517,7 +9326,7 @@
                           <ns0:r>
                             <a:rPr lang="en-US" sz="700">
                               <a:solidFill>
-                                <a:srgbClr val="1B1F2A"/>
+                                <a:srgbClr val="000000"/>
                               </a:solidFill>
                               <a:latin typeface="Cambria Math" panose="02040503050406030204" pitchFamily="18" charset="0"/>
                               <a:cs typeface="Cambria Math" panose="02040503050406030204" pitchFamily="18" charset="0"/>
@@ -9534,7 +9343,7 @@
                             </ns0:rPr>
                             <a:rPr lang="en-US" sz="700" b="1">
                               <a:solidFill>
-                                <a:srgbClr val="1B1F2A"/>
+                                <a:srgbClr val="000000"/>
                               </a:solidFill>
                               <a:latin typeface="Cambria Math" panose="02040503050406030204" pitchFamily="18" charset="0"/>
                               <a:cs typeface="Cambria Math" panose="02040503050406030204" pitchFamily="18" charset="0"/>
@@ -9549,7 +9358,7 @@
                         </ns0:rPr>
                         <a:rPr lang="en-US" sz="700">
                           <a:solidFill>
-                            <a:srgbClr val="1B1F2A"/>
+                            <a:srgbClr val="000000"/>
                           </a:solidFill>
                           <a:latin typeface="Cambria Math" panose="02040503050406030204" pitchFamily="18" charset="0"/>
                           <a:cs typeface="Cambria Math" panose="02040503050406030204" pitchFamily="18" charset="0"/>
@@ -9567,7 +9376,7 @@
                                 </ns0:rPr>
                                 <a:rPr lang="en-US" sz="700" i="1">
                                   <a:solidFill>
-                                    <a:srgbClr val="1B1F2A"/>
+                                    <a:srgbClr val="000000"/>
                                   </a:solidFill>
                                   <a:latin typeface="Cambria Math" panose="02040503050406030204" pitchFamily="18" charset="0"/>
                                   <a:cs typeface="Cambria Math" panose="02040503050406030204" pitchFamily="18" charset="0"/>
@@ -9584,7 +9393,7 @@
                             </ns0:rPr>
                             <a:rPr lang="en-US" sz="700" i="1">
                               <a:solidFill>
-                                <a:srgbClr val="1B1F2A"/>
+                                <a:srgbClr val="000000"/>
                               </a:solidFill>
                               <a:latin typeface="Cambria Math" panose="02040503050406030204" pitchFamily="18" charset="0"/>
                               <a:cs typeface="Cambria Math" panose="02040503050406030204" pitchFamily="18" charset="0"/>
@@ -9599,7 +9408,7 @@
                         </ns0:rPr>
                         <a:rPr lang="en-US" sz="700">
                           <a:solidFill>
-                            <a:srgbClr val="1B1F2A"/>
+                            <a:srgbClr val="000000"/>
                           </a:solidFill>
                           <a:latin typeface="Cambria Math" panose="02040503050406030204" pitchFamily="18" charset="0"/>
                           <a:cs typeface="Cambria Math" panose="02040503050406030204" pitchFamily="18" charset="0"/>
@@ -9611,7 +9420,7 @@
                           <ns0:r>
                             <a:rPr lang="en-US" sz="700">
                               <a:solidFill>
-                                <a:srgbClr val="1B1F2A"/>
+                                <a:srgbClr val="000000"/>
                               </a:solidFill>
                               <a:latin typeface="Cambria Math" panose="02040503050406030204" pitchFamily="18" charset="0"/>
                               <a:cs typeface="Cambria Math" panose="02040503050406030204" pitchFamily="18" charset="0"/>
@@ -9626,7 +9435,7 @@
                         </ns0:rPr>
                         <a:rPr lang="en-US" sz="700" i="1">
                           <a:solidFill>
-                            <a:srgbClr val="1B1F2A"/>
+                            <a:srgbClr val="000000"/>
                           </a:solidFill>
                           <a:latin typeface="Cambria Math" panose="02040503050406030204" pitchFamily="18" charset="0"/>
                           <a:cs typeface="Cambria Math" panose="02040503050406030204" pitchFamily="18" charset="0"/>
@@ -9639,7 +9448,7 @@
                         </ns0:rPr>
                         <a:rPr lang="en-US" sz="700">
                           <a:solidFill>
-                            <a:srgbClr val="1B1F2A"/>
+                            <a:srgbClr val="000000"/>
                           </a:solidFill>
                           <a:latin typeface="Cambria Math" panose="02040503050406030204" pitchFamily="18" charset="0"/>
                           <a:cs typeface="Cambria Math" panose="02040503050406030204" pitchFamily="18" charset="0"/>
@@ -9652,7 +9461,7 @@
                         </ns0:rPr>
                         <a:rPr lang="en-US" sz="700" i="1">
                           <a:solidFill>
-                            <a:srgbClr val="1B1F2A"/>
+                            <a:srgbClr val="000000"/>
                           </a:solidFill>
                           <a:latin typeface="Cambria Math" panose="02040503050406030204" pitchFamily="18" charset="0"/>
                           <a:cs typeface="Cambria Math" panose="02040503050406030204" pitchFamily="18" charset="0"/>
@@ -9670,20 +9479,20 @@
         <mc:Fallback>
           <p:sp>
             <p:nvSpPr>
-              <p:cNvPr id="57" name="TextBox 56"/>
+              <p:cNvPr id="53" name="TextBox 52"/>
               <p:cNvSpPr txBox="1"/>
               <p:nvPr/>
             </p:nvSpPr>
             <p:spPr>
               <a:xfrm>
-                <a:off x="538311" y="5243810"/>
-                <a:ext cx="2692598" cy="113854"/>
+                <a:off x="548134" y="6050756"/>
+                <a:ext cx="2682925" cy="126653"/>
               </a:xfrm>
               <a:prstGeom prst="rect">
                 <a:avLst/>
               </a:prstGeom>
               <a:blipFill>
-                <a:blip r:embed="rId20"/>
+                <a:blip r:embed="rId18"/>
                 <a:stretch>
                   <a:fillRect/>
                 </a:stretch>

</xml_diff>

<commit_message>
fix: scale AIJ logos by primary graphic marks
</commit_message>
<xml_diff>
--- a/plugins/paper-to-poster/skills/paper-to-poster/examples/compression_horizon_aij/poster.pptx
+++ b/plugins/paper-to-poster/skills/paper-to-poster/examples/compression_horizon_aij/poster.pptx
@@ -3867,8 +3867,8 @@
         </p:blipFill>
         <p:spPr>
           <a:xfrm>
-            <a:off x="2705695" y="9430494"/>
-            <a:ext cx="529233" cy="220266"/>
+            <a:off x="2705398" y="9443591"/>
+            <a:ext cx="744141" cy="309711"/>
           </a:xfrm>
           <a:prstGeom prst="rect">
             <a:avLst/>
@@ -3891,8 +3891,8 @@
         </p:blipFill>
         <p:spPr>
           <a:xfrm>
-            <a:off x="3342829" y="9430494"/>
-            <a:ext cx="919609" cy="220266"/>
+            <a:off x="3557439" y="9443591"/>
+            <a:ext cx="810220" cy="194072"/>
           </a:xfrm>
           <a:prstGeom prst="rect">
             <a:avLst/>
@@ -3915,8 +3915,8 @@
         </p:blipFill>
         <p:spPr>
           <a:xfrm>
-            <a:off x="4370338" y="9430494"/>
-            <a:ext cx="883146" cy="220266"/>
+            <a:off x="4475559" y="9443591"/>
+            <a:ext cx="778222" cy="194072"/>
           </a:xfrm>
           <a:prstGeom prst="rect">
             <a:avLst/>

</xml_diff>